<commit_message>
docs(review2): field-result slide and governed self-healing roadmap
Adds the Lending Club field-result slide and a next-phase slide framing Custos
as domain-agnostic and laying out governed self-healing. Each stage is marked
built, partly built or next phase; only detection is fully built today. The
work plan now names the first two self-healing steps. The deck is 24 slides.

Co-Authored-By: Claude Opus 5.5 <noreply@anthropic.com>
</commit_message>
<xml_diff>
--- a/docs/presentations/Custos_Phase2_Review2.pptx
+++ b/docs/presentations/Custos_Phase2_Review2.pptx
@@ -27,9 +27,11 @@
     <p:sldId id="272" r:id="rId25"/>
     <p:sldId id="273" r:id="rId26"/>
     <p:sldId id="274" r:id="rId27"/>
-    <p:sldId id="275" r:id="rId28"/>
-    <p:sldId id="276" r:id="rId29"/>
-    <p:sldId id="277" r:id="rId10"/>
+    <p:sldId id="275" r:id="rId30"/>
+    <p:sldId id="276" r:id="rId28"/>
+    <p:sldId id="277" r:id="rId31"/>
+    <p:sldId id="278" r:id="rId29"/>
+    <p:sldId id="279" r:id="rId10"/>
   </p:sldIdLst>
   <p:sldSz cx="12192000" cy="6858000"/>
   <p:notesSz cx="6858000" cy="9144000"/>
@@ -5815,7 +5817,7 @@
                 <a:ea typeface="Calibri" panose="020F0502020204030204" pitchFamily="34" charset="0"/>
                 <a:cs typeface="Calibri" panose="020F0502020204030204" pitchFamily="34" charset="0"/>
               </a:rPr>
-              <a:t>Seven rules, evaluated in order. New: the drift floor — a significantly drifted model is never auto-approved, however clean the other signals.</a:t>
+              <a:t>Seven rules, evaluated in order. New: the drift floor — a significantly drifted model is never auto-approved. Slide 20 tests it on real data.</a:t>
             </a:r>
           </a:p>
         </p:txBody>
@@ -6083,7 +6085,7 @@
                 <a:ea typeface="Calibri" panose="020F0502020204030204" pitchFamily="34" charset="0"/>
                 <a:cs typeface="Calibri" panose="020F0502020204030204" pitchFamily="34" charset="0"/>
               </a:rPr>
-              <a:t>Ten of twelve components complete. New since Review-1 are marked.</a:t>
+              <a:t>Eleven of twelve components complete. New since Review-1 are marked.</a:t>
             </a:r>
           </a:p>
         </p:txBody>
@@ -6873,7 +6875,7 @@
                         <a:rPr sz="950" b="0">
                           <a:latin typeface="Calibri"/>
                         </a:rPr>
-                        <a:t>Lending Club run</a:t>
+                        <a:t>Lending Club study</a:t>
                       </a:r>
                     </a:p>
                   </a:txBody>
@@ -6890,7 +6892,7 @@
                         <a:rPr sz="950" b="0">
                           <a:latin typeface="Calibri"/>
                         </a:rPr>
-                        <a:t>Field validation on 2.2M real loans, 2007–2018</a:t>
+                        <a:t>new — pre-registered field study on 589,186 matured loans; results committed</a:t>
                       </a:r>
                     </a:p>
                   </a:txBody>
@@ -6907,7 +6909,7 @@
                         <a:rPr sz="950" b="0">
                           <a:latin typeface="Calibri"/>
                         </a:rPr>
-                        <a:t>In progress</a:t>
+                        <a:t>Complete</a:t>
                       </a:r>
                     </a:p>
                   </a:txBody>
@@ -8701,7 +8703,7 @@
                 <a:ea typeface="Calibri" panose="020F0502020204030204" pitchFamily="34" charset="0"/>
                 <a:cs typeface="Calibri" panose="020F0502020204030204" pitchFamily="34" charset="0"/>
               </a:rPr>
-              <a:t>Validation — Field Data: Lending Club</a:t>
+              <a:t>Validation — Field Study: How It Was Run</a:t>
             </a:r>
           </a:p>
         </p:txBody>
@@ -8746,7 +8748,7 @@
                 <a:ea typeface="Calibri" panose="020F0502020204030204" pitchFamily="34" charset="0"/>
                 <a:cs typeface="Calibri" panose="020F0502020204030204" pitchFamily="34" charset="0"/>
               </a:rPr>
-              <a:t>Calibration proves the detector is correct. Field data proves it fires on drift nobody chose: ~2.2 million real loans, 2007–2018, across the 2008 crisis and the 2016 credit-policy change.</a:t>
+              <a:t>Calibration proves the detector is correct. A field study tests whether gating on drift actually helps: 2.26 million real Lending Club loans, of which 589,186 matured loans from 2012–2015 were evaluated against a model trained on 2007–2011.</a:t>
             </a:r>
           </a:p>
           <a:p>
@@ -8763,7 +8765,7 @@
                 <a:ea typeface="Calibri" panose="020F0502020204030204" pitchFamily="34" charset="0"/>
                 <a:cs typeface="Calibri" panose="020F0502020204030204" pitchFamily="34" charset="0"/>
               </a:rPr>
-              <a:t>Harness ready — reads the compressed file directly and scores quarterly windows against a fixed 2007 baseline, using the same code as the gateway.</a:t>
+              <a:t>Pre-registered — hypotheses, metrics and what each outcome would mean were committed and pushed before the dataset was even downloaded.</a:t>
             </a:r>
           </a:p>
           <a:p>
@@ -8780,7 +8782,7 @@
                 <a:ea typeface="Calibri" panose="020F0502020204030204" pitchFamily="34" charset="0"/>
                 <a:cs typeface="Calibri" panose="020F0502020204030204" pitchFamily="34" charset="0"/>
               </a:rPr>
-              <a:t>Bug found before the first run — dates sorted as text, so “Aug-2018” would have become the baseline. Fixed, with a regression test on Lending Club's own date format.</a:t>
+              <a:t>Leakage and censoring enforced in code — only fields known when the loan was made, and only loans whose term had ended, so outcomes are real.</a:t>
             </a:r>
           </a:p>
           <a:p>
@@ -8797,7 +8799,7 @@
                 <a:ea typeface="Calibri" panose="020F0502020204030204" pitchFamily="34" charset="0"/>
                 <a:cs typeface="Calibri" panose="020F0502020204030204" pitchFamily="34" charset="0"/>
               </a:rPr>
-              <a:t>Harness calibrated on a planted 2016 shift — found at the right quarter, with the right feature blamed.</a:t>
+              <a:t>Seven review strategies compared at the same review budget, from random review to the model's own risk score to Custos's drift gating.</a:t>
             </a:r>
           </a:p>
           <a:p>
@@ -8814,7 +8816,7 @@
                 <a:ea typeface="Calibri" panose="020F0502020204030204" pitchFamily="34" charset="0"/>
                 <a:cs typeface="Calibri" panose="020F0502020204030204" pitchFamily="34" charset="0"/>
               </a:rPr>
-              <a:t>Status: dataset run pending. Results will be reported as measured — the detector is not tuned to the data.</a:t>
+              <a:t>Two bugs caught before the real run — dates sorted as text, and a harm measure that could not see miscalibration. Both fixed, both recorded.</a:t>
             </a:r>
           </a:p>
         </p:txBody>
@@ -9195,7 +9197,7 @@
                 <a:ea typeface="Calibri" panose="020F0502020204030204" pitchFamily="34" charset="0"/>
                 <a:cs typeface="Calibri" panose="020F0502020204030204" pitchFamily="34" charset="0"/>
               </a:rPr>
-              <a:t>Engineering rigour, work plan and conclusion</a:t>
+              <a:t>Engineering rigour, next phase (self-healing), work plan, conclusion</a:t>
             </a:r>
           </a:p>
         </p:txBody>
@@ -9394,7 +9396,7 @@
                 <a:ea typeface="Calibri" panose="020F0502020204030204" pitchFamily="34" charset="0"/>
                 <a:cs typeface="Calibri" panose="020F0502020204030204" pitchFamily="34" charset="0"/>
               </a:rPr>
-              <a:t>Engineering Rigour — Defects We Found in Our Own System</a:t>
+              <a:t>Field Result — Our Core Assumption Failed</a:t>
             </a:r>
           </a:p>
         </p:txBody>
@@ -9434,12 +9436,12 @@
               <a:buNone/>
             </a:pPr>
             <a:r>
-              <a:rPr lang="en-US" sz="1300" b="0" i="0" dirty="0">
+              <a:rPr lang="en-US" sz="1400" b="0" i="0" dirty="0">
                 <a:latin typeface="Calibri" panose="020F0502020204030204" pitchFamily="34" charset="0"/>
                 <a:ea typeface="Calibri" panose="020F0502020204030204" pitchFamily="34" charset="0"/>
                 <a:cs typeface="Calibri" panose="020F0502020204030204" pitchFamily="34" charset="0"/>
               </a:rPr>
-              <a:t>Five defects, none visible to a test that sends one request at a time. Two were introduced and caught during this phase.</a:t>
+              <a:t>Asked to pick 5% of 589,186 real loans for human review, gating on population drift — how Custos works today — caught fewer defaults than picking at random. The model's own risk score caught 2.1× random.</a:t>
             </a:r>
           </a:p>
         </p:txBody>
@@ -9568,378 +9570,30 @@
           </a:p>
         </p:txBody>
       </p:sp>
-      <p:graphicFrame>
-        <p:nvGraphicFramePr>
-          <p:cNvPr id="8" name="Table 7"/>
-          <p:cNvGraphicFramePr>
-            <a:graphicFrameLocks noGrp="1"/>
-          </p:cNvGraphicFramePr>
+      <p:pic>
+        <p:nvPicPr>
+          <p:cNvPr id="8" name="Picture 7" descr="gating_results.png"/>
+          <p:cNvPicPr>
+            <a:picLocks noChangeAspect="1"/>
+          </p:cNvPicPr>
           <p:nvPr/>
-        </p:nvGraphicFramePr>
-        <p:xfrm>
-          <a:off x="960120" y="2331720"/>
-          <a:ext cx="10241279" cy="152400"/>
-        </p:xfrm>
-        <a:graphic>
-          <a:graphicData uri="http://schemas.openxmlformats.org/drawingml/2006/table">
-            <a:tbl>
-              <a:tblPr firstRow="1">
-                <a:tableStyleId>{5C22544A-7EE6-4342-B048-85BDC9FD1C3A}</a:tableStyleId>
-              </a:tblPr>
-              <a:tblGrid>
-                <a:gridCol w="1741017"/>
-                <a:gridCol w="4915814"/>
-                <a:gridCol w="3584448"/>
-              </a:tblGrid>
-              <a:tr h="25400">
-                <a:tc>
-                  <a:txBody>
-                    <a:bodyPr wrap="square"/>
-                    <a:lstStyle/>
-                    <a:p>
-                      <a:r>
-                        <a:rPr sz="1100" b="1">
-                          <a:solidFill>
-                            <a:srgbClr val="FFFFFF"/>
-                          </a:solidFill>
-                          <a:latin typeface="Calibri"/>
-                        </a:rPr>
-                        <a:t>Found by</a:t>
-                      </a:r>
-                    </a:p>
-                  </a:txBody>
-                  <a:tcPr marL="63500" marR="63500" marT="38100" marB="38100">
-                    <a:solidFill>
-                      <a:srgbClr val="1F5CA8"/>
-                    </a:solidFill>
-                  </a:tcPr>
-                </a:tc>
-                <a:tc>
-                  <a:txBody>
-                    <a:bodyPr wrap="square"/>
-                    <a:lstStyle/>
-                    <a:p>
-                      <a:r>
-                        <a:rPr sz="1100" b="1">
-                          <a:solidFill>
-                            <a:srgbClr val="FFFFFF"/>
-                          </a:solidFill>
-                          <a:latin typeface="Calibri"/>
-                        </a:rPr>
-                        <a:t>Defect</a:t>
-                      </a:r>
-                    </a:p>
-                  </a:txBody>
-                  <a:tcPr marL="63500" marR="63500" marT="38100" marB="38100">
-                    <a:solidFill>
-                      <a:srgbClr val="1F5CA8"/>
-                    </a:solidFill>
-                  </a:tcPr>
-                </a:tc>
-                <a:tc>
-                  <a:txBody>
-                    <a:bodyPr wrap="square"/>
-                    <a:lstStyle/>
-                    <a:p>
-                      <a:r>
-                        <a:rPr sz="1100" b="1">
-                          <a:solidFill>
-                            <a:srgbClr val="FFFFFF"/>
-                          </a:solidFill>
-                          <a:latin typeface="Calibri"/>
-                        </a:rPr>
-                        <a:t>Fix</a:t>
-                      </a:r>
-                    </a:p>
-                  </a:txBody>
-                  <a:tcPr marL="63500" marR="63500" marT="38100" marB="38100">
-                    <a:solidFill>
-                      <a:srgbClr val="1F5CA8"/>
-                    </a:solidFill>
-                  </a:tcPr>
-                </a:tc>
-              </a:tr>
-              <a:tr h="25400">
-                <a:tc>
-                  <a:txBody>
-                    <a:bodyPr wrap="square"/>
-                    <a:lstStyle/>
-                    <a:p>
-                      <a:r>
-                        <a:rPr sz="1100" b="0">
-                          <a:latin typeface="Calibri"/>
-                        </a:rPr>
-                        <a:t>Load harness (R1)</a:t>
-                      </a:r>
-                    </a:p>
-                  </a:txBody>
-                  <a:tcPr marL="63500" marR="63500" marT="38100" marB="38100">
-                    <a:noFill/>
-                  </a:tcPr>
-                </a:tc>
-                <a:tc>
-                  <a:txBody>
-                    <a:bodyPr wrap="square"/>
-                    <a:lstStyle/>
-                    <a:p>
-                      <a:r>
-                        <a:rPr sz="1100" b="0">
-                          <a:latin typeface="Calibri"/>
-                        </a:rPr>
-                        <a:t>Published p99 of 0.5 ms measured a timer that stops before the audit write; real figure was 49 ms</a:t>
-                      </a:r>
-                    </a:p>
-                  </a:txBody>
-                  <a:tcPr marL="63500" marR="63500" marT="38100" marB="38100">
-                    <a:noFill/>
-                  </a:tcPr>
-                </a:tc>
-                <a:tc>
-                  <a:txBody>
-                    <a:bodyPr wrap="square"/>
-                    <a:lstStyle/>
-                    <a:p>
-                      <a:r>
-                        <a:rPr sz="1100" b="0">
-                          <a:latin typeface="Calibri"/>
-                        </a:rPr>
-                        <a:t>Report client-observed latency; now 9 ms at the same rate</a:t>
-                      </a:r>
-                    </a:p>
-                  </a:txBody>
-                  <a:tcPr marL="63500" marR="63500" marT="38100" marB="38100">
-                    <a:noFill/>
-                  </a:tcPr>
-                </a:tc>
-              </a:tr>
-              <a:tr h="25400">
-                <a:tc>
-                  <a:txBody>
-                    <a:bodyPr wrap="square"/>
-                    <a:lstStyle/>
-                    <a:p>
-                      <a:r>
-                        <a:rPr sz="1100" b="0">
-                          <a:latin typeface="Calibri"/>
-                        </a:rPr>
-                        <a:t>Load harness (R1)</a:t>
-                      </a:r>
-                    </a:p>
-                  </a:txBody>
-                  <a:tcPr marL="63500" marR="63500" marT="38100" marB="38100">
-                    <a:solidFill>
-                      <a:srgbClr val="F4F6F9"/>
-                    </a:solidFill>
-                  </a:tcPr>
-                </a:tc>
-                <a:tc>
-                  <a:txBody>
-                    <a:bodyPr wrap="square"/>
-                    <a:lstStyle/>
-                    <a:p>
-                      <a:r>
-                        <a:rPr sz="1100" b="0">
-                          <a:latin typeface="Calibri"/>
-                        </a:rPr>
-                        <a:t>Audit chain dropped entries under concurrency and still verified as intact</a:t>
-                      </a:r>
-                    </a:p>
-                  </a:txBody>
-                  <a:tcPr marL="63500" marR="63500" marT="38100" marB="38100">
-                    <a:solidFill>
-                      <a:srgbClr val="F4F6F9"/>
-                    </a:solidFill>
-                  </a:tcPr>
-                </a:tc>
-                <a:tc>
-                  <a:txBody>
-                    <a:bodyPr wrap="square"/>
-                    <a:lstStyle/>
-                    <a:p>
-                      <a:r>
-                        <a:rPr sz="1100" b="0">
-                          <a:latin typeface="Calibri"/>
-                        </a:rPr>
-                        <a:t>Advisory lock + jittered backoff; 0 lost from 2 to 48 writers</a:t>
-                      </a:r>
-                    </a:p>
-                  </a:txBody>
-                  <a:tcPr marL="63500" marR="63500" marT="38100" marB="38100">
-                    <a:solidFill>
-                      <a:srgbClr val="F4F6F9"/>
-                    </a:solidFill>
-                  </a:tcPr>
-                </a:tc>
-              </a:tr>
-              <a:tr h="25400">
-                <a:tc>
-                  <a:txBody>
-                    <a:bodyPr wrap="square"/>
-                    <a:lstStyle/>
-                    <a:p>
-                      <a:r>
-                        <a:rPr sz="1100" b="0">
-                          <a:latin typeface="Calibri"/>
-                        </a:rPr>
-                        <a:t>Load harness (R1)</a:t>
-                      </a:r>
-                    </a:p>
-                  </a:txBody>
-                  <a:tcPr marL="63500" marR="63500" marT="38100" marB="38100">
-                    <a:noFill/>
-                  </a:tcPr>
-                </a:tc>
-                <a:tc>
-                  <a:txBody>
-                    <a:bodyPr wrap="square"/>
-                    <a:lstStyle/>
-                    <a:p>
-                      <a:r>
-                        <a:rPr sz="1100" b="0">
-                          <a:latin typeface="Calibri"/>
-                        </a:rPr>
-                        <a:t>Overload changed verdicts: ~13% flipped ALLOW → REVIEW</a:t>
-                      </a:r>
-                    </a:p>
-                  </a:txBody>
-                  <a:tcPr marL="63500" marR="63500" marT="38100" marB="38100">
-                    <a:noFill/>
-                  </a:tcPr>
-                </a:tc>
-                <a:tc>
-                  <a:txBody>
-                    <a:bodyPr wrap="square"/>
-                    <a:lstStyle/>
-                    <a:p>
-                      <a:r>
-                        <a:rPr sz="1100" b="0">
-                          <a:latin typeface="Calibri"/>
-                        </a:rPr>
-                        <a:t>Event loop unblocked + admission control: 0 flips under overload</a:t>
-                      </a:r>
-                    </a:p>
-                  </a:txBody>
-                  <a:tcPr marL="63500" marR="63500" marT="38100" marB="38100">
-                    <a:noFill/>
-                  </a:tcPr>
-                </a:tc>
-              </a:tr>
-              <a:tr h="25400">
-                <a:tc>
-                  <a:txBody>
-                    <a:bodyPr wrap="square"/>
-                    <a:lstStyle/>
-                    <a:p>
-                      <a:r>
-                        <a:rPr sz="1100" b="0">
-                          <a:latin typeface="Calibri"/>
-                        </a:rPr>
-                        <a:t>Unit test (R2)</a:t>
-                      </a:r>
-                    </a:p>
-                  </a:txBody>
-                  <a:tcPr marL="63500" marR="63500" marT="38100" marB="38100">
-                    <a:solidFill>
-                      <a:srgbClr val="F4F6F9"/>
-                    </a:solidFill>
-                  </a:tcPr>
-                </a:tc>
-                <a:tc>
-                  <a:txBody>
-                    <a:bodyPr wrap="square"/>
-                    <a:lstStyle/>
-                    <a:p>
-                      <a:r>
-                        <a:rPr sz="1100" b="0">
-                          <a:latin typeface="Calibri"/>
-                        </a:rPr>
-                        <a:t>Replay harness sorted dates as text — “Aug-2018” became the 2007 baseline</a:t>
-                      </a:r>
-                    </a:p>
-                  </a:txBody>
-                  <a:tcPr marL="63500" marR="63500" marT="38100" marB="38100">
-                    <a:solidFill>
-                      <a:srgbClr val="F4F6F9"/>
-                    </a:solidFill>
-                  </a:tcPr>
-                </a:tc>
-                <a:tc>
-                  <a:txBody>
-                    <a:bodyPr wrap="square"/>
-                    <a:lstStyle/>
-                    <a:p>
-                      <a:r>
-                        <a:rPr sz="1100" b="0">
-                          <a:latin typeface="Calibri"/>
-                        </a:rPr>
-                        <a:t>Parse dates; regression test on Lending Club's own date format</a:t>
-                      </a:r>
-                    </a:p>
-                  </a:txBody>
-                  <a:tcPr marL="63500" marR="63500" marT="38100" marB="38100">
-                    <a:solidFill>
-                      <a:srgbClr val="F4F6F9"/>
-                    </a:solidFill>
-                  </a:tcPr>
-                </a:tc>
-              </a:tr>
-              <a:tr h="25400">
-                <a:tc>
-                  <a:txBody>
-                    <a:bodyPr wrap="square"/>
-                    <a:lstStyle/>
-                    <a:p>
-                      <a:r>
-                        <a:rPr sz="1100" b="0">
-                          <a:latin typeface="Calibri"/>
-                        </a:rPr>
-                        <a:t>Fusion arithmetic (R2)</a:t>
-                      </a:r>
-                    </a:p>
-                  </a:txBody>
-                  <a:tcPr marL="63500" marR="63500" marT="38100" marB="38100">
-                    <a:noFill/>
-                  </a:tcPr>
-                </a:tc>
-                <a:tc>
-                  <a:txBody>
-                    <a:bodyPr wrap="square"/>
-                    <a:lstStyle/>
-                    <a:p>
-                      <a:r>
-                        <a:rPr sz="1100" b="0">
-                          <a:latin typeface="Calibri"/>
-                        </a:rPr>
-                        <a:t>Adding a live risk signal let a significantly drifted model reach ALLOW</a:t>
-                      </a:r>
-                    </a:p>
-                  </a:txBody>
-                  <a:tcPr marL="63500" marR="63500" marT="38100" marB="38100">
-                    <a:noFill/>
-                  </a:tcPr>
-                </a:tc>
-                <a:tc>
-                  <a:txBody>
-                    <a:bodyPr wrap="square"/>
-                    <a:lstStyle/>
-                    <a:p>
-                      <a:r>
-                        <a:rPr sz="1100" b="0">
-                          <a:latin typeface="Calibri"/>
-                        </a:rPr>
-                        <a:t>Explicit drift-floor rule in the decision cascade, pinned by tests</a:t>
-                      </a:r>
-                    </a:p>
-                  </a:txBody>
-                  <a:tcPr marL="63500" marR="63500" marT="38100" marB="38100">
-                    <a:noFill/>
-                  </a:tcPr>
-                </a:tc>
-              </a:tr>
-            </a:tbl>
-          </a:graphicData>
-        </a:graphic>
-      </p:graphicFrame>
+        </p:nvPicPr>
+        <p:blipFill>
+          <a:blip r:embed="rId4"/>
+          <a:stretch>
+            <a:fillRect/>
+          </a:stretch>
+        </p:blipFill>
+        <p:spPr>
+          <a:xfrm>
+            <a:off x="1066647" y="2514600"/>
+            <a:ext cx="10058400" cy="3017520"/>
+          </a:xfrm>
+          <a:prstGeom prst="rect">
+            <a:avLst/>
+          </a:prstGeom>
+        </p:spPr>
+      </p:pic>
     </p:spTree>
     <p:extLst>
       <p:ext uri="{BB962C8B-B14F-4D97-AF65-F5344CB8AC3E}">
@@ -10010,7 +9664,7 @@
                 <a:ea typeface="Calibri" panose="020F0502020204030204" pitchFamily="34" charset="0"/>
                 <a:cs typeface="Calibri" panose="020F0502020204030204" pitchFamily="34" charset="0"/>
               </a:rPr>
-              <a:t>Work Plan to the Final Review</a:t>
+              <a:t>Engineering Rigour — Problems We Found in Our Own System</a:t>
             </a:r>
           </a:p>
         </p:txBody>
@@ -10050,12 +9704,12 @@
               <a:buNone/>
             </a:pPr>
             <a:r>
-              <a:rPr lang="en-US" sz="1400" b="0" i="0" dirty="0">
+              <a:rPr lang="en-US" sz="1300" b="0" i="0" dirty="0">
                 <a:latin typeface="Calibri" panose="020F0502020204030204" pitchFamily="34" charset="0"/>
                 <a:ea typeface="Calibri" panose="020F0502020204030204" pitchFamily="34" charset="0"/>
                 <a:cs typeface="Calibri" panose="020F0502020204030204" pitchFamily="34" charset="0"/>
               </a:rPr>
-              <a:t>What remains, and what each item depends on.</a:t>
+              <a:t>Six problems, found by our own tooling. The last is the largest: real data contradicted the assumption the gating was built on.</a:t>
             </a:r>
           </a:p>
         </p:txBody>
@@ -10193,7 +9847,7 @@
           <p:nvPr/>
         </p:nvGraphicFramePr>
         <p:xfrm>
-          <a:off x="960120" y="2194560"/>
+          <a:off x="960120" y="2331720"/>
           <a:ext cx="10241279" cy="177800"/>
         </p:xfrm>
         <a:graphic>
@@ -10203,9 +9857,9 @@
                 <a:tableStyleId>{5C22544A-7EE6-4342-B048-85BDC9FD1C3A}</a:tableStyleId>
               </a:tblPr>
               <a:tblGrid>
-                <a:gridCol w="3072384"/>
+                <a:gridCol w="1741017"/>
                 <a:gridCol w="4915814"/>
-                <a:gridCol w="2253081"/>
+                <a:gridCol w="3584448"/>
               </a:tblGrid>
               <a:tr h="25400">
                 <a:tc>
@@ -10220,7 +9874,7 @@
                           </a:solidFill>
                           <a:latin typeface="Calibri"/>
                         </a:rPr>
-                        <a:t>Item</a:t>
+                        <a:t>Found by</a:t>
                       </a:r>
                     </a:p>
                   </a:txBody>
@@ -10242,7 +9896,7 @@
                           </a:solidFill>
                           <a:latin typeface="Calibri"/>
                         </a:rPr>
-                        <a:t>Why it matters</a:t>
+                        <a:t>Defect</a:t>
                       </a:r>
                     </a:p>
                   </a:txBody>
@@ -10264,7 +9918,7 @@
                           </a:solidFill>
                           <a:latin typeface="Calibri"/>
                         </a:rPr>
-                        <a:t>Depends on</a:t>
+                        <a:t>Fix</a:t>
                       </a:r>
                     </a:p>
                   </a:txBody>
@@ -10285,7 +9939,7 @@
                         <a:rPr sz="1100" b="0">
                           <a:latin typeface="Calibri"/>
                         </a:rPr>
-                        <a:t>Lending Club field validation</a:t>
+                        <a:t>Load harness (R1)</a:t>
                       </a:r>
                     </a:p>
                   </a:txBody>
@@ -10302,7 +9956,7 @@
                         <a:rPr sz="1100" b="0">
                           <a:latin typeface="Calibri"/>
                         </a:rPr>
-                        <a:t>Real drift nobody chose — the field half of validation</a:t>
+                        <a:t>Published p99 of 0.5 ms measured a timer that stops before the audit write; real figure was 49 ms</a:t>
                       </a:r>
                     </a:p>
                   </a:txBody>
@@ -10319,7 +9973,7 @@
                         <a:rPr sz="1100" b="0">
                           <a:latin typeface="Calibri"/>
                         </a:rPr>
-                        <a:t>Dataset download (ready to run)</a:t>
+                        <a:t>Report client-observed latency; now 9 ms at the same rate</a:t>
                       </a:r>
                     </a:p>
                   </a:txBody>
@@ -10338,7 +9992,7 @@
                         <a:rPr sz="1100" b="0">
                           <a:latin typeface="Calibri"/>
                         </a:rPr>
-                        <a:t>Scale-out: multiple gateway workers</a:t>
+                        <a:t>Load harness (R1)</a:t>
                       </a:r>
                     </a:p>
                   </a:txBody>
@@ -10357,7 +10011,7 @@
                         <a:rPr sz="1100" b="0">
                           <a:latin typeface="Calibri"/>
                         </a:rPr>
-                        <a:t>One process saturates near 300 req/s; past that, requests queue before the gate can see them</a:t>
+                        <a:t>Audit chain dropped entries under concurrency and still verified as intact</a:t>
                       </a:r>
                     </a:p>
                   </a:txBody>
@@ -10376,7 +10030,7 @@
                         <a:rPr sz="1100" b="0">
                           <a:latin typeface="Calibri"/>
                         </a:rPr>
-                        <a:t>Postgres for shared state</a:t>
+                        <a:t>Advisory lock + jittered backoff; 0 lost from 2 to 48 writers</a:t>
                       </a:r>
                     </a:p>
                   </a:txBody>
@@ -10397,7 +10051,7 @@
                         <a:rPr sz="1100" b="0">
                           <a:latin typeface="Calibri"/>
                         </a:rPr>
-                        <a:t>Postgres load measurement</a:t>
+                        <a:t>Load harness (R1)</a:t>
                       </a:r>
                     </a:p>
                   </a:txBody>
@@ -10414,7 +10068,7 @@
                         <a:rPr sz="1100" b="0">
                           <a:latin typeface="Calibri"/>
                         </a:rPr>
-                        <a:t>SQLite is the pessimistic floor; production runs Postgres</a:t>
+                        <a:t>Overload changed verdicts: ~13% flipped ALLOW → REVIEW</a:t>
                       </a:r>
                     </a:p>
                   </a:txBody>
@@ -10431,7 +10085,7 @@
                         <a:rPr sz="1100" b="0">
                           <a:latin typeface="Calibri"/>
                         </a:rPr>
-                        <a:t>Docker</a:t>
+                        <a:t>Event loop unblocked + admission control: 0 flips under overload</a:t>
                       </a:r>
                     </a:p>
                   </a:txBody>
@@ -10450,7 +10104,7 @@
                         <a:rPr sz="1100" b="0">
                           <a:latin typeface="Calibri"/>
                         </a:rPr>
-                        <a:t>Model / data versioning + retraining trigger</a:t>
+                        <a:t>Unit test (R2)</a:t>
                       </a:r>
                     </a:p>
                   </a:txBody>
@@ -10469,7 +10123,7 @@
                         <a:rPr sz="1100" b="0">
                           <a:latin typeface="Calibri"/>
                         </a:rPr>
-                        <a:t>What practitioners named as prerequisites</a:t>
+                        <a:t>Replay harness sorted dates as text — “Aug-2018” became the 2007 baseline</a:t>
                       </a:r>
                     </a:p>
                   </a:txBody>
@@ -10488,7 +10142,7 @@
                         <a:rPr sz="1100" b="0">
                           <a:latin typeface="Calibri"/>
                         </a:rPr>
-                        <a:t>—</a:t>
+                        <a:t>Parse dates; regression test on Lending Club's own date format</a:t>
                       </a:r>
                     </a:p>
                   </a:txBody>
@@ -10509,7 +10163,7 @@
                         <a:rPr sz="1100" b="0">
                           <a:latin typeface="Calibri"/>
                         </a:rPr>
-                        <a:t>Pipeline-break vs population-shift signal</a:t>
+                        <a:t>Fusion arithmetic (R2)</a:t>
                       </a:r>
                     </a:p>
                   </a:txBody>
@@ -10526,7 +10180,7 @@
                         <a:rPr sz="1100" b="0">
                           <a:latin typeface="Calibri"/>
                         </a:rPr>
-                        <a:t>One dead feed needs a different response from a real shift</a:t>
+                        <a:t>Adding a live risk signal let a significantly drifted model reach ALLOW</a:t>
                       </a:r>
                     </a:p>
                   </a:txBody>
@@ -10543,7 +10197,7 @@
                         <a:rPr sz="1100" b="0">
                           <a:latin typeface="Calibri"/>
                         </a:rPr>
-                        <a:t>—</a:t>
+                        <a:t>Explicit drift-floor rule in the decision cascade, pinned by tests</a:t>
                       </a:r>
                     </a:p>
                   </a:txBody>
@@ -10562,7 +10216,7 @@
                         <a:rPr sz="1100" b="0">
                           <a:latin typeface="Calibri"/>
                         </a:rPr>
-                        <a:t>Final report and paper draft</a:t>
+                        <a:t>Pre-registered study (R2)</a:t>
                       </a:r>
                     </a:p>
                   </a:txBody>
@@ -10581,7 +10235,7 @@
                         <a:rPr sz="1100" b="0">
                           <a:latin typeface="Calibri"/>
                         </a:rPr>
-                        <a:t>Department submission</a:t>
+                        <a:t>On real loans, drift gating caught fewer defaults than random; the drift floor would escalate 92% of decisions for no gain</a:t>
                       </a:r>
                     </a:p>
                   </a:txBody>
@@ -10600,7 +10254,7 @@
                         <a:rPr sz="1100" b="0">
                           <a:latin typeface="Calibri"/>
                         </a:rPr>
-                        <a:t>All of the above</a:t>
+                        <a:t>Not yet fixed — gating to be rebuilt around risk-ranked review</a:t>
                       </a:r>
                     </a:p>
                   </a:txBody>
@@ -10685,7 +10339,7 @@
                 <a:ea typeface="Calibri" panose="020F0502020204030204" pitchFamily="34" charset="0"/>
                 <a:cs typeface="Calibri" panose="020F0502020204030204" pitchFamily="34" charset="0"/>
               </a:rPr>
-              <a:t>Conclusion</a:t>
+              <a:t>Next Phase — From Gating to Governed Self-Healing</a:t>
             </a:r>
           </a:p>
         </p:txBody>
@@ -10725,12 +10379,1024 @@
               <a:buNone/>
             </a:pPr>
             <a:r>
+              <a:rPr lang="en-US" sz="1300" b="0" i="0" dirty="0">
+                <a:latin typeface="Calibri" panose="020F0502020204030204" pitchFamily="34" charset="0"/>
+                <a:ea typeface="Calibri" panose="020F0502020204030204" pitchFamily="34" charset="0"/>
+                <a:cs typeface="Calibri" panose="020F0502020204030204" pitchFamily="34" charset="0"/>
+              </a:rPr>
+              <a:t>Custos is domain-agnostic MLOps infrastructure: it gates any model whose output triggers an action. Our field study showed drift is a poor per-decision gate but a strong alarm — so next it triggers a repair, tested in shadow and applied only with human approval.</a:t>
+            </a:r>
+          </a:p>
+        </p:txBody>
+      </p:sp>
+      <p:pic>
+        <p:nvPicPr>
+          <p:cNvPr id="5" name="Graphic 4">
+            <a:extLst>
+              <a:ext uri="{FF2B5EF4-FFF2-40B4-BE49-F238E27FC236}">
+                <a16:creationId xmlns:a16="http://schemas.microsoft.com/office/drawing/2014/main" id="{E7125167-8301-4D88-B79A-A8DA3C19E0D6}"/>
+              </a:ext>
+            </a:extLst>
+          </p:cNvPr>
+          <p:cNvPicPr>
+            <a:picLocks noChangeAspect="1"/>
+          </p:cNvPicPr>
+          <p:nvPr/>
+        </p:nvPicPr>
+        <p:blipFill>
+          <a:blip r:embed="rId2">
+            <a:extLst>
+              <a:ext uri="{96DAC541-7B7A-43D3-8B79-37D633B846F1}">
+                <asvg:svgBlip xmlns:asvg="http://schemas.microsoft.com/office/drawing/2016/SVG/main" r:embed="rId3"/>
+              </a:ext>
+            </a:extLst>
+          </a:blip>
+          <a:stretch>
+            <a:fillRect/>
+          </a:stretch>
+        </p:blipFill>
+        <p:spPr>
+          <a:xfrm>
+            <a:off x="127001" y="86782"/>
+            <a:ext cx="1159932" cy="1159932"/>
+          </a:xfrm>
+          <a:prstGeom prst="rect">
+            <a:avLst/>
+          </a:prstGeom>
+        </p:spPr>
+      </p:pic>
+      <p:sp>
+        <p:nvSpPr>
+          <p:cNvPr id="4" name="Date Placeholder 3">
+            <a:extLst>
+              <a:ext uri="{FF2B5EF4-FFF2-40B4-BE49-F238E27FC236}">
+                <a16:creationId xmlns:a16="http://schemas.microsoft.com/office/drawing/2014/main" id="{35032362-C5A5-4DBF-AD79-DE6FB7439999}"/>
+              </a:ext>
+            </a:extLst>
+          </p:cNvPr>
+          <p:cNvSpPr>
+            <a:spLocks noGrp="1"/>
+          </p:cNvSpPr>
+          <p:nvPr>
+            <p:ph type="dt" sz="half" idx="10"/>
+          </p:nvPr>
+        </p:nvSpPr>
+        <p:spPr/>
+        <p:txBody>
+          <a:bodyPr/>
+          <a:lstStyle/>
+          <a:p>
+            <a:fld id="{64C96E34-94C0-49E4-A53B-4A44141FD3C8}" type="datetime3">
+              <a:rPr lang="en-US" smtClean="0"/>
+              <a:t>17 October 2026</a:t>
+            </a:fld>
+            <a:endParaRPr lang="en-US" dirty="0"/>
+          </a:p>
+        </p:txBody>
+      </p:sp>
+      <p:sp>
+        <p:nvSpPr>
+          <p:cNvPr id="6" name="Slide Number Placeholder 5">
+            <a:extLst>
+              <a:ext uri="{FF2B5EF4-FFF2-40B4-BE49-F238E27FC236}">
+                <a16:creationId xmlns:a16="http://schemas.microsoft.com/office/drawing/2014/main" id="{115AAB64-5B51-4B5A-B69E-D96362CE6E74}"/>
+              </a:ext>
+            </a:extLst>
+          </p:cNvPr>
+          <p:cNvSpPr>
+            <a:spLocks noGrp="1"/>
+          </p:cNvSpPr>
+          <p:nvPr>
+            <p:ph type="sldNum" sz="quarter" idx="12"/>
+          </p:nvPr>
+        </p:nvSpPr>
+        <p:spPr/>
+        <p:txBody>
+          <a:bodyPr/>
+          <a:lstStyle/>
+          <a:p>
+            <a:fld id="{D57F1E4F-1CFF-5643-939E-217C01CDF565}" type="slidenum">
+              <a:rPr lang="en-US" smtClean="0"/>
+              <a:pPr/>
+              <a:t>3</a:t>
+            </a:fld>
+            <a:endParaRPr lang="en-US" dirty="0"/>
+          </a:p>
+        </p:txBody>
+      </p:sp>
+      <p:sp>
+        <p:nvSpPr>
+          <p:cNvPr id="7" name="Footer Placeholder 6">
+            <a:extLst>
+              <a:ext uri="{FF2B5EF4-FFF2-40B4-BE49-F238E27FC236}">
+                <a16:creationId xmlns:a16="http://schemas.microsoft.com/office/drawing/2014/main" id="{8683C6DF-27D9-468B-A1AB-FE568488FE57}"/>
+              </a:ext>
+            </a:extLst>
+          </p:cNvPr>
+          <p:cNvSpPr>
+            <a:spLocks noGrp="1"/>
+          </p:cNvSpPr>
+          <p:nvPr>
+            <p:ph type="ftr" sz="quarter" idx="11"/>
+          </p:nvPr>
+        </p:nvSpPr>
+        <p:spPr/>
+        <p:txBody>
+          <a:bodyPr/>
+          <a:lstStyle/>
+          <a:p>
+            <a:r>
+              <a:rPr lang="en-US"/>
+              <a:t>Dept of AI &amp; DS</a:t>
+            </a:r>
+            <a:endParaRPr lang="en-US" dirty="0"/>
+          </a:p>
+        </p:txBody>
+      </p:sp>
+      <p:pic>
+        <p:nvPicPr>
+          <p:cNvPr id="8" name="Picture 7" descr="self_healing_loop.png"/>
+          <p:cNvPicPr>
+            <a:picLocks noChangeAspect="1"/>
+          </p:cNvPicPr>
+          <p:nvPr/>
+        </p:nvPicPr>
+        <p:blipFill>
+          <a:blip r:embed="rId4"/>
+          <a:stretch>
+            <a:fillRect/>
+          </a:stretch>
+        </p:blipFill>
+        <p:spPr>
+          <a:xfrm>
+            <a:off x="1066647" y="2697480"/>
+            <a:ext cx="10058400" cy="2148840"/>
+          </a:xfrm>
+          <a:prstGeom prst="rect">
+            <a:avLst/>
+          </a:prstGeom>
+        </p:spPr>
+      </p:pic>
+    </p:spTree>
+    <p:extLst>
+      <p:ext uri="{BB962C8B-B14F-4D97-AF65-F5344CB8AC3E}">
+        <p14:creationId xmlns:p14="http://schemas.microsoft.com/office/powerpoint/2010/main" val="3231882420"/>
+      </p:ext>
+    </p:extLst>
+  </p:cSld>
+  <p:clrMapOvr>
+    <a:masterClrMapping/>
+  </p:clrMapOvr>
+</p:sld>
+</file>
+
+<file path=ppt/slides/slide23.xml><?xml version="1.0" encoding="utf-8"?>
+<p:sld xmlns:a="http://schemas.openxmlformats.org/drawingml/2006/main" xmlns:r="http://schemas.openxmlformats.org/officeDocument/2006/relationships" xmlns:p="http://schemas.openxmlformats.org/presentationml/2006/main">
+  <p:cSld>
+    <p:spTree>
+      <p:nvGrpSpPr>
+        <p:cNvPr id="1" name=""/>
+        <p:cNvGrpSpPr/>
+        <p:nvPr/>
+      </p:nvGrpSpPr>
+      <p:grpSpPr>
+        <a:xfrm>
+          <a:off x="0" y="0"/>
+          <a:ext cx="0" cy="0"/>
+          <a:chOff x="0" y="0"/>
+          <a:chExt cx="0" cy="0"/>
+        </a:xfrm>
+      </p:grpSpPr>
+      <p:sp>
+        <p:nvSpPr>
+          <p:cNvPr id="2" name="Title 1">
+            <a:extLst>
+              <a:ext uri="{FF2B5EF4-FFF2-40B4-BE49-F238E27FC236}">
+                <a16:creationId xmlns:a16="http://schemas.microsoft.com/office/drawing/2014/main" id="{BD1A189D-22D1-4D1A-9E04-C6134EC51F8B}"/>
+              </a:ext>
+            </a:extLst>
+          </p:cNvPr>
+          <p:cNvSpPr>
+            <a:spLocks noGrp="1"/>
+          </p:cNvSpPr>
+          <p:nvPr>
+            <p:ph type="ctrTitle"/>
+          </p:nvPr>
+        </p:nvSpPr>
+        <p:spPr>
+          <a:xfrm>
+            <a:off x="1684868" y="203198"/>
+            <a:ext cx="9694332" cy="880535"/>
+          </a:xfrm>
+        </p:spPr>
+        <p:txBody>
+          <a:bodyPr>
+            <a:normAutofit/>
+          </a:bodyPr>
+          <a:lstStyle/>
+          <a:p>
+            <a:pPr marL="0" indent="0" algn="l">
+              <a:spcBef>
+                <a:spcPts val="0"/>
+              </a:spcBef>
+              <a:buNone/>
+            </a:pPr>
+            <a:r>
+              <a:rPr lang="en-US" sz="3200" b="1" i="0" dirty="0">
+                <a:latin typeface="Calibri" panose="020F0502020204030204" pitchFamily="34" charset="0"/>
+                <a:ea typeface="Calibri" panose="020F0502020204030204" pitchFamily="34" charset="0"/>
+                <a:cs typeface="Calibri" panose="020F0502020204030204" pitchFamily="34" charset="0"/>
+              </a:rPr>
+              <a:t>Work Plan to the Final Review</a:t>
+            </a:r>
+          </a:p>
+        </p:txBody>
+      </p:sp>
+      <p:sp>
+        <p:nvSpPr>
+          <p:cNvPr id="3" name="Subtitle 2">
+            <a:extLst>
+              <a:ext uri="{FF2B5EF4-FFF2-40B4-BE49-F238E27FC236}">
+                <a16:creationId xmlns:a16="http://schemas.microsoft.com/office/drawing/2014/main" id="{255E737C-85F2-47BC-AD38-AD8B001473B7}"/>
+              </a:ext>
+            </a:extLst>
+          </p:cNvPr>
+          <p:cNvSpPr>
+            <a:spLocks noGrp="1"/>
+          </p:cNvSpPr>
+          <p:nvPr>
+            <p:ph type="subTitle" idx="1"/>
+          </p:nvPr>
+        </p:nvSpPr>
+        <p:spPr>
+          <a:xfrm>
+            <a:off x="1684867" y="1574800"/>
+            <a:ext cx="9694333" cy="4614333"/>
+          </a:xfrm>
+        </p:spPr>
+        <p:txBody>
+          <a:bodyPr>
+            <a:normAutofit/>
+          </a:bodyPr>
+          <a:lstStyle/>
+          <a:p>
+            <a:pPr marL="0" indent="0" algn="l">
+              <a:spcBef>
+                <a:spcPts val="0"/>
+              </a:spcBef>
+              <a:buNone/>
+            </a:pPr>
+            <a:r>
+              <a:rPr lang="en-US" sz="1400" b="0" i="0" dirty="0">
+                <a:latin typeface="Calibri" panose="020F0502020204030204" pitchFamily="34" charset="0"/>
+                <a:ea typeface="Calibri" panose="020F0502020204030204" pitchFamily="34" charset="0"/>
+                <a:cs typeface="Calibri" panose="020F0502020204030204" pitchFamily="34" charset="0"/>
+              </a:rPr>
+              <a:t>What remains, and what each item depends on.</a:t>
+            </a:r>
+          </a:p>
+        </p:txBody>
+      </p:sp>
+      <p:pic>
+        <p:nvPicPr>
+          <p:cNvPr id="5" name="Graphic 4">
+            <a:extLst>
+              <a:ext uri="{FF2B5EF4-FFF2-40B4-BE49-F238E27FC236}">
+                <a16:creationId xmlns:a16="http://schemas.microsoft.com/office/drawing/2014/main" id="{E7125167-8301-4D88-B79A-A8DA3C19E0D6}"/>
+              </a:ext>
+            </a:extLst>
+          </p:cNvPr>
+          <p:cNvPicPr>
+            <a:picLocks noChangeAspect="1"/>
+          </p:cNvPicPr>
+          <p:nvPr/>
+        </p:nvPicPr>
+        <p:blipFill>
+          <a:blip r:embed="rId2">
+            <a:extLst>
+              <a:ext uri="{96DAC541-7B7A-43D3-8B79-37D633B846F1}">
+                <asvg:svgBlip xmlns:asvg="http://schemas.microsoft.com/office/drawing/2016/SVG/main" r:embed="rId3"/>
+              </a:ext>
+            </a:extLst>
+          </a:blip>
+          <a:stretch>
+            <a:fillRect/>
+          </a:stretch>
+        </p:blipFill>
+        <p:spPr>
+          <a:xfrm>
+            <a:off x="127001" y="86782"/>
+            <a:ext cx="1159932" cy="1159932"/>
+          </a:xfrm>
+          <a:prstGeom prst="rect">
+            <a:avLst/>
+          </a:prstGeom>
+        </p:spPr>
+      </p:pic>
+      <p:sp>
+        <p:nvSpPr>
+          <p:cNvPr id="4" name="Date Placeholder 3">
+            <a:extLst>
+              <a:ext uri="{FF2B5EF4-FFF2-40B4-BE49-F238E27FC236}">
+                <a16:creationId xmlns:a16="http://schemas.microsoft.com/office/drawing/2014/main" id="{35032362-C5A5-4DBF-AD79-DE6FB7439999}"/>
+              </a:ext>
+            </a:extLst>
+          </p:cNvPr>
+          <p:cNvSpPr>
+            <a:spLocks noGrp="1"/>
+          </p:cNvSpPr>
+          <p:nvPr>
+            <p:ph type="dt" sz="half" idx="10"/>
+          </p:nvPr>
+        </p:nvSpPr>
+        <p:spPr/>
+        <p:txBody>
+          <a:bodyPr/>
+          <a:lstStyle/>
+          <a:p>
+            <a:fld id="{64C96E34-94C0-49E4-A53B-4A44141FD3C8}" type="datetime3">
+              <a:rPr lang="en-US" smtClean="0"/>
+              <a:t>17 October 2026</a:t>
+            </a:fld>
+            <a:endParaRPr lang="en-US" dirty="0"/>
+          </a:p>
+        </p:txBody>
+      </p:sp>
+      <p:sp>
+        <p:nvSpPr>
+          <p:cNvPr id="6" name="Slide Number Placeholder 5">
+            <a:extLst>
+              <a:ext uri="{FF2B5EF4-FFF2-40B4-BE49-F238E27FC236}">
+                <a16:creationId xmlns:a16="http://schemas.microsoft.com/office/drawing/2014/main" id="{115AAB64-5B51-4B5A-B69E-D96362CE6E74}"/>
+              </a:ext>
+            </a:extLst>
+          </p:cNvPr>
+          <p:cNvSpPr>
+            <a:spLocks noGrp="1"/>
+          </p:cNvSpPr>
+          <p:nvPr>
+            <p:ph type="sldNum" sz="quarter" idx="12"/>
+          </p:nvPr>
+        </p:nvSpPr>
+        <p:spPr/>
+        <p:txBody>
+          <a:bodyPr/>
+          <a:lstStyle/>
+          <a:p>
+            <a:fld id="{D57F1E4F-1CFF-5643-939E-217C01CDF565}" type="slidenum">
+              <a:rPr lang="en-US" smtClean="0"/>
+              <a:pPr/>
+              <a:t>3</a:t>
+            </a:fld>
+            <a:endParaRPr lang="en-US" dirty="0"/>
+          </a:p>
+        </p:txBody>
+      </p:sp>
+      <p:sp>
+        <p:nvSpPr>
+          <p:cNvPr id="7" name="Footer Placeholder 6">
+            <a:extLst>
+              <a:ext uri="{FF2B5EF4-FFF2-40B4-BE49-F238E27FC236}">
+                <a16:creationId xmlns:a16="http://schemas.microsoft.com/office/drawing/2014/main" id="{8683C6DF-27D9-468B-A1AB-FE568488FE57}"/>
+              </a:ext>
+            </a:extLst>
+          </p:cNvPr>
+          <p:cNvSpPr>
+            <a:spLocks noGrp="1"/>
+          </p:cNvSpPr>
+          <p:nvPr>
+            <p:ph type="ftr" sz="quarter" idx="11"/>
+          </p:nvPr>
+        </p:nvSpPr>
+        <p:spPr/>
+        <p:txBody>
+          <a:bodyPr/>
+          <a:lstStyle/>
+          <a:p>
+            <a:r>
+              <a:rPr lang="en-US"/>
+              <a:t>Dept of AI &amp; DS</a:t>
+            </a:r>
+            <a:endParaRPr lang="en-US" dirty="0"/>
+          </a:p>
+        </p:txBody>
+      </p:sp>
+      <p:graphicFrame>
+        <p:nvGraphicFramePr>
+          <p:cNvPr id="8" name="Table 7"/>
+          <p:cNvGraphicFramePr>
+            <a:graphicFrameLocks noGrp="1"/>
+          </p:cNvGraphicFramePr>
+          <p:nvPr/>
+        </p:nvGraphicFramePr>
+        <p:xfrm>
+          <a:off x="960120" y="2194560"/>
+          <a:ext cx="10241279" cy="203200"/>
+        </p:xfrm>
+        <a:graphic>
+          <a:graphicData uri="http://schemas.openxmlformats.org/drawingml/2006/table">
+            <a:tbl>
+              <a:tblPr firstRow="1">
+                <a:tableStyleId>{5C22544A-7EE6-4342-B048-85BDC9FD1C3A}</a:tableStyleId>
+              </a:tblPr>
+              <a:tblGrid>
+                <a:gridCol w="3072384"/>
+                <a:gridCol w="4915814"/>
+                <a:gridCol w="2253081"/>
+              </a:tblGrid>
+              <a:tr h="25400">
+                <a:tc>
+                  <a:txBody>
+                    <a:bodyPr wrap="square"/>
+                    <a:lstStyle/>
+                    <a:p>
+                      <a:r>
+                        <a:rPr sz="1100" b="1">
+                          <a:solidFill>
+                            <a:srgbClr val="FFFFFF"/>
+                          </a:solidFill>
+                          <a:latin typeface="Calibri"/>
+                        </a:rPr>
+                        <a:t>Item</a:t>
+                      </a:r>
+                    </a:p>
+                  </a:txBody>
+                  <a:tcPr marL="63500" marR="63500" marT="38100" marB="38100">
+                    <a:solidFill>
+                      <a:srgbClr val="1F5CA8"/>
+                    </a:solidFill>
+                  </a:tcPr>
+                </a:tc>
+                <a:tc>
+                  <a:txBody>
+                    <a:bodyPr wrap="square"/>
+                    <a:lstStyle/>
+                    <a:p>
+                      <a:r>
+                        <a:rPr sz="1100" b="1">
+                          <a:solidFill>
+                            <a:srgbClr val="FFFFFF"/>
+                          </a:solidFill>
+                          <a:latin typeface="Calibri"/>
+                        </a:rPr>
+                        <a:t>Why it matters</a:t>
+                      </a:r>
+                    </a:p>
+                  </a:txBody>
+                  <a:tcPr marL="63500" marR="63500" marT="38100" marB="38100">
+                    <a:solidFill>
+                      <a:srgbClr val="1F5CA8"/>
+                    </a:solidFill>
+                  </a:tcPr>
+                </a:tc>
+                <a:tc>
+                  <a:txBody>
+                    <a:bodyPr wrap="square"/>
+                    <a:lstStyle/>
+                    <a:p>
+                      <a:r>
+                        <a:rPr sz="1100" b="1">
+                          <a:solidFill>
+                            <a:srgbClr val="FFFFFF"/>
+                          </a:solidFill>
+                          <a:latin typeface="Calibri"/>
+                        </a:rPr>
+                        <a:t>Depends on</a:t>
+                      </a:r>
+                    </a:p>
+                  </a:txBody>
+                  <a:tcPr marL="63500" marR="63500" marT="38100" marB="38100">
+                    <a:solidFill>
+                      <a:srgbClr val="1F5CA8"/>
+                    </a:solidFill>
+                  </a:tcPr>
+                </a:tc>
+              </a:tr>
+              <a:tr h="25400">
+                <a:tc>
+                  <a:txBody>
+                    <a:bodyPr wrap="square"/>
+                    <a:lstStyle/>
+                    <a:p>
+                      <a:r>
+                        <a:rPr sz="1100" b="0">
+                          <a:latin typeface="Calibri"/>
+                        </a:rPr>
+                        <a:t>Rebuild gating around risk-ranked review</a:t>
+                      </a:r>
+                    </a:p>
+                  </a:txBody>
+                  <a:tcPr marL="63500" marR="63500" marT="38100" marB="38100">
+                    <a:noFill/>
+                  </a:tcPr>
+                </a:tc>
+                <a:tc>
+                  <a:txBody>
+                    <a:bodyPr wrap="square"/>
+                    <a:lstStyle/>
+                    <a:p>
+                      <a:r>
+                        <a:rPr sz="1100" b="0">
+                          <a:latin typeface="Calibri"/>
+                        </a:rPr>
+                        <a:t>On real loans the model's risk ranking caught 2.1× random; drift gating caught less than random</a:t>
+                      </a:r>
+                    </a:p>
+                  </a:txBody>
+                  <a:tcPr marL="63500" marR="63500" marT="38100" marB="38100">
+                    <a:noFill/>
+                  </a:tcPr>
+                </a:tc>
+                <a:tc>
+                  <a:txBody>
+                    <a:bodyPr wrap="square"/>
+                    <a:lstStyle/>
+                    <a:p>
+                      <a:r>
+                        <a:rPr sz="1100" b="0">
+                          <a:latin typeface="Calibri"/>
+                        </a:rPr>
+                        <a:t>—</a:t>
+                      </a:r>
+                    </a:p>
+                  </a:txBody>
+                  <a:tcPr marL="63500" marR="63500" marT="38100" marB="38100">
+                    <a:noFill/>
+                  </a:tcPr>
+                </a:tc>
+              </a:tr>
+              <a:tr h="25400">
+                <a:tc>
+                  <a:txBody>
+                    <a:bodyPr wrap="square"/>
+                    <a:lstStyle/>
+                    <a:p>
+                      <a:r>
+                        <a:rPr sz="1100" b="0">
+                          <a:latin typeface="Calibri"/>
+                        </a:rPr>
+                        <a:t>Replicate on a second credit dataset</a:t>
+                      </a:r>
+                    </a:p>
+                  </a:txBody>
+                  <a:tcPr marL="63500" marR="63500" marT="38100" marB="38100">
+                    <a:solidFill>
+                      <a:srgbClr val="F4F6F9"/>
+                    </a:solidFill>
+                  </a:tcPr>
+                </a:tc>
+                <a:tc>
+                  <a:txBody>
+                    <a:bodyPr wrap="square"/>
+                    <a:lstStyle/>
+                    <a:p>
+                      <a:r>
+                        <a:rPr sz="1100" b="0">
+                          <a:latin typeface="Calibri"/>
+                        </a:rPr>
+                        <a:t>One dataset cannot support a general claim</a:t>
+                      </a:r>
+                    </a:p>
+                  </a:txBody>
+                  <a:tcPr marL="63500" marR="63500" marT="38100" marB="38100">
+                    <a:solidFill>
+                      <a:srgbClr val="F4F6F9"/>
+                    </a:solidFill>
+                  </a:tcPr>
+                </a:tc>
+                <a:tc>
+                  <a:txBody>
+                    <a:bodyPr wrap="square"/>
+                    <a:lstStyle/>
+                    <a:p>
+                      <a:r>
+                        <a:rPr sz="1100" b="0">
+                          <a:latin typeface="Calibri"/>
+                        </a:rPr>
+                        <a:t>Dataset access</a:t>
+                      </a:r>
+                    </a:p>
+                  </a:txBody>
+                  <a:tcPr marL="63500" marR="63500" marT="38100" marB="38100">
+                    <a:solidFill>
+                      <a:srgbClr val="F4F6F9"/>
+                    </a:solidFill>
+                  </a:tcPr>
+                </a:tc>
+              </a:tr>
+              <a:tr h="25400">
+                <a:tc>
+                  <a:txBody>
+                    <a:bodyPr wrap="square"/>
+                    <a:lstStyle/>
+                    <a:p>
+                      <a:r>
+                        <a:rPr sz="1100" b="0">
+                          <a:latin typeface="Calibri"/>
+                        </a:rPr>
+                        <a:t>Scale-out: multiple gateway workers</a:t>
+                      </a:r>
+                    </a:p>
+                  </a:txBody>
+                  <a:tcPr marL="63500" marR="63500" marT="38100" marB="38100">
+                    <a:noFill/>
+                  </a:tcPr>
+                </a:tc>
+                <a:tc>
+                  <a:txBody>
+                    <a:bodyPr wrap="square"/>
+                    <a:lstStyle/>
+                    <a:p>
+                      <a:r>
+                        <a:rPr sz="1100" b="0">
+                          <a:latin typeface="Calibri"/>
+                        </a:rPr>
+                        <a:t>One process saturates near 300 req/s; past that, requests queue before the gate can see them</a:t>
+                      </a:r>
+                    </a:p>
+                  </a:txBody>
+                  <a:tcPr marL="63500" marR="63500" marT="38100" marB="38100">
+                    <a:noFill/>
+                  </a:tcPr>
+                </a:tc>
+                <a:tc>
+                  <a:txBody>
+                    <a:bodyPr wrap="square"/>
+                    <a:lstStyle/>
+                    <a:p>
+                      <a:r>
+                        <a:rPr sz="1100" b="0">
+                          <a:latin typeface="Calibri"/>
+                        </a:rPr>
+                        <a:t>Postgres for shared state</a:t>
+                      </a:r>
+                    </a:p>
+                  </a:txBody>
+                  <a:tcPr marL="63500" marR="63500" marT="38100" marB="38100">
+                    <a:noFill/>
+                  </a:tcPr>
+                </a:tc>
+              </a:tr>
+              <a:tr h="25400">
+                <a:tc>
+                  <a:txBody>
+                    <a:bodyPr wrap="square"/>
+                    <a:lstStyle/>
+                    <a:p>
+                      <a:r>
+                        <a:rPr sz="1100" b="0">
+                          <a:latin typeface="Calibri"/>
+                        </a:rPr>
+                        <a:t>Postgres load measurement</a:t>
+                      </a:r>
+                    </a:p>
+                  </a:txBody>
+                  <a:tcPr marL="63500" marR="63500" marT="38100" marB="38100">
+                    <a:solidFill>
+                      <a:srgbClr val="F4F6F9"/>
+                    </a:solidFill>
+                  </a:tcPr>
+                </a:tc>
+                <a:tc>
+                  <a:txBody>
+                    <a:bodyPr wrap="square"/>
+                    <a:lstStyle/>
+                    <a:p>
+                      <a:r>
+                        <a:rPr sz="1100" b="0">
+                          <a:latin typeface="Calibri"/>
+                        </a:rPr>
+                        <a:t>SQLite is the pessimistic floor; production runs Postgres</a:t>
+                      </a:r>
+                    </a:p>
+                  </a:txBody>
+                  <a:tcPr marL="63500" marR="63500" marT="38100" marB="38100">
+                    <a:solidFill>
+                      <a:srgbClr val="F4F6F9"/>
+                    </a:solidFill>
+                  </a:tcPr>
+                </a:tc>
+                <a:tc>
+                  <a:txBody>
+                    <a:bodyPr wrap="square"/>
+                    <a:lstStyle/>
+                    <a:p>
+                      <a:r>
+                        <a:rPr sz="1100" b="0">
+                          <a:latin typeface="Calibri"/>
+                        </a:rPr>
+                        <a:t>Docker</a:t>
+                      </a:r>
+                    </a:p>
+                  </a:txBody>
+                  <a:tcPr marL="63500" marR="63500" marT="38100" marB="38100">
+                    <a:solidFill>
+                      <a:srgbClr val="F4F6F9"/>
+                    </a:solidFill>
+                  </a:tcPr>
+                </a:tc>
+              </a:tr>
+              <a:tr h="25400">
+                <a:tc>
+                  <a:txBody>
+                    <a:bodyPr wrap="square"/>
+                    <a:lstStyle/>
+                    <a:p>
+                      <a:r>
+                        <a:rPr sz="1100" b="0">
+                          <a:latin typeface="Calibri"/>
+                        </a:rPr>
+                        <a:t>Self-healing step 1: broken-feed detection + proposed rollback, in shadow</a:t>
+                      </a:r>
+                    </a:p>
+                  </a:txBody>
+                  <a:tcPr marL="63500" marR="63500" marT="38100" marB="38100">
+                    <a:noFill/>
+                  </a:tcPr>
+                </a:tc>
+                <a:tc>
+                  <a:txBody>
+                    <a:bodyPr wrap="square"/>
+                    <a:lstStyle/>
+                    <a:p>
+                      <a:r>
+                        <a:rPr sz="1100" b="0">
+                          <a:latin typeface="Calibri"/>
+                        </a:rPr>
+                        <a:t>A dead input feed needs a different repair from a real population shift</a:t>
+                      </a:r>
+                    </a:p>
+                  </a:txBody>
+                  <a:tcPr marL="63500" marR="63500" marT="38100" marB="38100">
+                    <a:noFill/>
+                  </a:tcPr>
+                </a:tc>
+                <a:tc>
+                  <a:txBody>
+                    <a:bodyPr wrap="square"/>
+                    <a:lstStyle/>
+                    <a:p>
+                      <a:r>
+                        <a:rPr sz="1100" b="0">
+                          <a:latin typeface="Calibri"/>
+                        </a:rPr>
+                        <a:t>Model versioning</a:t>
+                      </a:r>
+                    </a:p>
+                  </a:txBody>
+                  <a:tcPr marL="63500" marR="63500" marT="38100" marB="38100">
+                    <a:noFill/>
+                  </a:tcPr>
+                </a:tc>
+              </a:tr>
+              <a:tr h="25400">
+                <a:tc>
+                  <a:txBody>
+                    <a:bodyPr wrap="square"/>
+                    <a:lstStyle/>
+                    <a:p>
+                      <a:r>
+                        <a:rPr sz="1100" b="0">
+                          <a:latin typeface="Calibri"/>
+                        </a:rPr>
+                        <a:t>Self-healing step 2: human approval queue; every repair on the audit chain</a:t>
+                      </a:r>
+                    </a:p>
+                  </a:txBody>
+                  <a:tcPr marL="63500" marR="63500" marT="38100" marB="38100">
+                    <a:solidFill>
+                      <a:srgbClr val="F4F6F9"/>
+                    </a:solidFill>
+                  </a:tcPr>
+                </a:tc>
+                <a:tc>
+                  <a:txBody>
+                    <a:bodyPr wrap="square"/>
+                    <a:lstStyle/>
+                    <a:p>
+                      <a:r>
+                        <a:rPr sz="1100" b="0">
+                          <a:latin typeface="Calibri"/>
+                        </a:rPr>
+                        <a:t>No repair is applied without a person and a tamper-evident record</a:t>
+                      </a:r>
+                    </a:p>
+                  </a:txBody>
+                  <a:tcPr marL="63500" marR="63500" marT="38100" marB="38100">
+                    <a:solidFill>
+                      <a:srgbClr val="F4F6F9"/>
+                    </a:solidFill>
+                  </a:tcPr>
+                </a:tc>
+                <a:tc>
+                  <a:txBody>
+                    <a:bodyPr wrap="square"/>
+                    <a:lstStyle/>
+                    <a:p>
+                      <a:r>
+                        <a:rPr sz="1100" b="0">
+                          <a:latin typeface="Calibri"/>
+                        </a:rPr>
+                        <a:t>Step 1</a:t>
+                      </a:r>
+                    </a:p>
+                  </a:txBody>
+                  <a:tcPr marL="63500" marR="63500" marT="38100" marB="38100">
+                    <a:solidFill>
+                      <a:srgbClr val="F4F6F9"/>
+                    </a:solidFill>
+                  </a:tcPr>
+                </a:tc>
+              </a:tr>
+              <a:tr h="25400">
+                <a:tc>
+                  <a:txBody>
+                    <a:bodyPr wrap="square"/>
+                    <a:lstStyle/>
+                    <a:p>
+                      <a:r>
+                        <a:rPr sz="1100" b="0">
+                          <a:latin typeface="Calibri"/>
+                        </a:rPr>
+                        <a:t>Final report and paper draft</a:t>
+                      </a:r>
+                    </a:p>
+                  </a:txBody>
+                  <a:tcPr marL="63500" marR="63500" marT="38100" marB="38100">
+                    <a:noFill/>
+                  </a:tcPr>
+                </a:tc>
+                <a:tc>
+                  <a:txBody>
+                    <a:bodyPr wrap="square"/>
+                    <a:lstStyle/>
+                    <a:p>
+                      <a:r>
+                        <a:rPr sz="1100" b="0">
+                          <a:latin typeface="Calibri"/>
+                        </a:rPr>
+                        <a:t>Department submission</a:t>
+                      </a:r>
+                    </a:p>
+                  </a:txBody>
+                  <a:tcPr marL="63500" marR="63500" marT="38100" marB="38100">
+                    <a:noFill/>
+                  </a:tcPr>
+                </a:tc>
+                <a:tc>
+                  <a:txBody>
+                    <a:bodyPr wrap="square"/>
+                    <a:lstStyle/>
+                    <a:p>
+                      <a:r>
+                        <a:rPr sz="1100" b="0">
+                          <a:latin typeface="Calibri"/>
+                        </a:rPr>
+                        <a:t>All of the above</a:t>
+                      </a:r>
+                    </a:p>
+                  </a:txBody>
+                  <a:tcPr marL="63500" marR="63500" marT="38100" marB="38100">
+                    <a:noFill/>
+                  </a:tcPr>
+                </a:tc>
+              </a:tr>
+            </a:tbl>
+          </a:graphicData>
+        </a:graphic>
+      </p:graphicFrame>
+    </p:spTree>
+    <p:extLst>
+      <p:ext uri="{BB962C8B-B14F-4D97-AF65-F5344CB8AC3E}">
+        <p14:creationId xmlns:p14="http://schemas.microsoft.com/office/powerpoint/2010/main" val="3231882420"/>
+      </p:ext>
+    </p:extLst>
+  </p:cSld>
+  <p:clrMapOvr>
+    <a:masterClrMapping/>
+  </p:clrMapOvr>
+</p:sld>
+</file>
+
+<file path=ppt/slides/slide24.xml><?xml version="1.0" encoding="utf-8"?>
+<p:sld xmlns:a="http://schemas.openxmlformats.org/drawingml/2006/main" xmlns:r="http://schemas.openxmlformats.org/officeDocument/2006/relationships" xmlns:p="http://schemas.openxmlformats.org/presentationml/2006/main">
+  <p:cSld>
+    <p:spTree>
+      <p:nvGrpSpPr>
+        <p:cNvPr id="1" name=""/>
+        <p:cNvGrpSpPr/>
+        <p:nvPr/>
+      </p:nvGrpSpPr>
+      <p:grpSpPr>
+        <a:xfrm>
+          <a:off x="0" y="0"/>
+          <a:ext cx="0" cy="0"/>
+          <a:chOff x="0" y="0"/>
+          <a:chExt cx="0" cy="0"/>
+        </a:xfrm>
+      </p:grpSpPr>
+      <p:sp>
+        <p:nvSpPr>
+          <p:cNvPr id="2" name="Title 1">
+            <a:extLst>
+              <a:ext uri="{FF2B5EF4-FFF2-40B4-BE49-F238E27FC236}">
+                <a16:creationId xmlns:a16="http://schemas.microsoft.com/office/drawing/2014/main" id="{BD1A189D-22D1-4D1A-9E04-C6134EC51F8B}"/>
+              </a:ext>
+            </a:extLst>
+          </p:cNvPr>
+          <p:cNvSpPr>
+            <a:spLocks noGrp="1"/>
+          </p:cNvSpPr>
+          <p:nvPr>
+            <p:ph type="ctrTitle"/>
+          </p:nvPr>
+        </p:nvSpPr>
+        <p:spPr>
+          <a:xfrm>
+            <a:off x="1684868" y="203198"/>
+            <a:ext cx="9694332" cy="880535"/>
+          </a:xfrm>
+        </p:spPr>
+        <p:txBody>
+          <a:bodyPr>
+            <a:normAutofit/>
+          </a:bodyPr>
+          <a:lstStyle/>
+          <a:p>
+            <a:pPr marL="0" indent="0" algn="l">
+              <a:spcBef>
+                <a:spcPts val="0"/>
+              </a:spcBef>
+              <a:buNone/>
+            </a:pPr>
+            <a:r>
+              <a:rPr lang="en-US" sz="3200" b="1" i="0" dirty="0">
+                <a:latin typeface="Calibri" panose="020F0502020204030204" pitchFamily="34" charset="0"/>
+                <a:ea typeface="Calibri" panose="020F0502020204030204" pitchFamily="34" charset="0"/>
+                <a:cs typeface="Calibri" panose="020F0502020204030204" pitchFamily="34" charset="0"/>
+              </a:rPr>
+              <a:t>Conclusion</a:t>
+            </a:r>
+          </a:p>
+        </p:txBody>
+      </p:sp>
+      <p:sp>
+        <p:nvSpPr>
+          <p:cNvPr id="3" name="Subtitle 2">
+            <a:extLst>
+              <a:ext uri="{FF2B5EF4-FFF2-40B4-BE49-F238E27FC236}">
+                <a16:creationId xmlns:a16="http://schemas.microsoft.com/office/drawing/2014/main" id="{255E737C-85F2-47BC-AD38-AD8B001473B7}"/>
+              </a:ext>
+            </a:extLst>
+          </p:cNvPr>
+          <p:cNvSpPr>
+            <a:spLocks noGrp="1"/>
+          </p:cNvSpPr>
+          <p:nvPr>
+            <p:ph type="subTitle" idx="1"/>
+          </p:nvPr>
+        </p:nvSpPr>
+        <p:spPr>
+          <a:xfrm>
+            <a:off x="1684867" y="1574800"/>
+            <a:ext cx="9694333" cy="4614333"/>
+          </a:xfrm>
+        </p:spPr>
+        <p:txBody>
+          <a:bodyPr>
+            <a:normAutofit/>
+          </a:bodyPr>
+          <a:lstStyle/>
+          <a:p>
+            <a:pPr marL="0" indent="0" algn="l">
+              <a:spcBef>
+                <a:spcPts val="0"/>
+              </a:spcBef>
+              <a:buNone/>
+            </a:pPr>
+            <a:r>
               <a:rPr lang="en-US" sz="1400" b="1" i="0" dirty="0">
                 <a:latin typeface="Calibri" panose="020F0502020204030204" pitchFamily="34" charset="0"/>
                 <a:ea typeface="Calibri" panose="020F0502020204030204" pitchFamily="34" charset="0"/>
                 <a:cs typeface="Calibri" panose="020F0502020204030204" pitchFamily="34" charset="0"/>
               </a:rPr>
-              <a:t>304 tests passing · latency budget holds to 200 req/s, double Review-1 · overload no longer changes verdicts · all three trust signals live.</a:t>
+              <a:t>342 tests passing · latency budget holds to 200 req/s, double Review-1 · overload no longer changes verdicts · all three trust signals live.</a:t>
+            </a:r>
+          </a:p>
+          <a:p>
+            <a:pPr marL="0" indent="0" algn="l">
+              <a:spcBef>
+                <a:spcPts val="200"/>
+              </a:spcBef>
+              <a:buNone/>
+            </a:pPr>
+            <a:r>
+              <a:rPr lang="en-US" sz="1300" b="0" i="0" dirty="0">
+                <a:latin typeface="Calibri" panose="020F0502020204030204" pitchFamily="34" charset="0"/>
+                <a:ea typeface="Calibri" panose="020F0502020204030204" pitchFamily="34" charset="0"/>
+                <a:cs typeface="Calibri" panose="020F0502020204030204" pitchFamily="34" charset="0"/>
+              </a:rPr>
+              <a:t>And the hardest result: on 589,186 real loans, gating on drift did worse than random review. Pre-registered, reported as measured — and it now decides what we build next.</a:t>
             </a:r>
           </a:p>
         </p:txBody>
@@ -11106,7 +11772,7 @@
                         <a:rPr sz="1100" b="0">
                           <a:latin typeface="Calibri"/>
                         </a:rPr>
-                        <a:t>Python SDK · React operator dashboard · fintech demonstration · 304-test suite across unit, integration and end-to-end</a:t>
+                        <a:t>Python SDK · React operator dashboard · fintech demonstration · 342-test suite across unit, integration and end-to-end</a:t>
                       </a:r>
                     </a:p>
                   </a:txBody>
@@ -11266,7 +11932,7 @@
                 <a:ea typeface="Calibri" panose="020F0502020204030204" pitchFamily="34" charset="0"/>
                 <a:cs typeface="Calibri" panose="020F0502020204030204" pitchFamily="34" charset="0"/>
               </a:rPr>
-              <a:t>The detector is validated by calibration against shifts of known size; the gateway by open-loop load testing. Our own tooling has found five defects in the system, all fixed and pinned by tests.</a:t>
+              <a:t>The detector is validated by calibration against shifts of known size, the gateway by open-loop load testing, and the gating idea itself by a pre-registered study on 589,186 real loans. That study found that gating on population drift catches fewer bad loans than random review. We report it as measured, and it now decides what we build next.</a:t>
             </a:r>
           </a:p>
         </p:txBody>
@@ -11869,7 +12535,7 @@
                         <a:rPr sz="1100" b="0">
                           <a:latin typeface="Calibri"/>
                         </a:rPr>
-                        <a:t>In progress</a:t>
+                        <a:t>Done — negative</a:t>
                       </a:r>
                     </a:p>
                   </a:txBody>
@@ -11886,7 +12552,7 @@
                         <a:rPr sz="1100" b="0">
                           <a:latin typeface="Calibri"/>
                         </a:rPr>
-                        <a:t>Replay harness hardened: reads .gz directly, quarterly windows, and a date-ordering bug found and fixed. Dataset run pending download</a:t>
+                        <a:t>Pre-registered study, 589,186 real loans: drift gating caught fewer defaults than random review. Reported as measured</a:t>
                       </a:r>
                     </a:p>
                   </a:txBody>

</xml_diff>

<commit_message>
docs(review2): "Beyond Lending" slide — where Custos applies, stated honestly
New slide 23 (deck is now 25 slides). It covers six domains: lending, AI agents,
dynamic pricing, medical triage, hiring and insurance claims. For each it gives
the action Custos gates and what it catches. Lending and the AI refund agent are
marked demonstrated; the rest "applies by configuration". The EU AI Act
high-risk label appears only where Annex III names the use: credit,
recruitment and emergency triage.

The speech notes add the slide's script, where Custos does not fit, and a ready
answer for "this market is crowded — how would it survive?". Later slides are
renumbered.

Co-Authored-By: Claude Opus 5.5 <noreply@anthropic.com>
</commit_message>
<xml_diff>
--- a/docs/presentations/Custos_Phase2_Review2.pptx
+++ b/docs/presentations/Custos_Phase2_Review2.pptx
@@ -30,8 +30,9 @@
     <p:sldId id="275" r:id="rId30"/>
     <p:sldId id="276" r:id="rId28"/>
     <p:sldId id="277" r:id="rId31"/>
-    <p:sldId id="278" r:id="rId29"/>
-    <p:sldId id="279" r:id="rId10"/>
+    <p:sldId id="278" r:id="rId32"/>
+    <p:sldId id="279" r:id="rId29"/>
+    <p:sldId id="280" r:id="rId10"/>
   </p:sldIdLst>
   <p:sldSz cx="12192000" cy="6858000"/>
   <p:notesSz cx="6858000" cy="9144000"/>
@@ -9250,7 +9251,7 @@
                 <a:ea typeface="Calibri" panose="020F0502020204030204" pitchFamily="34" charset="0"/>
                 <a:cs typeface="Calibri" panose="020F0502020204030204" pitchFamily="34" charset="0"/>
               </a:rPr>
-              <a:t>Engineering rigour, governed self-healing, work plan, conclusion</a:t>
+              <a:t>Engineering rigour, self-healing, other domains, work plan, conclusion</a:t>
             </a:r>
           </a:p>
         </p:txBody>
@@ -10713,6 +10714,812 @@
                 <a:ea typeface="Calibri" panose="020F0502020204030204" pitchFamily="34" charset="0"/>
                 <a:cs typeface="Calibri" panose="020F0502020204030204" pitchFamily="34" charset="0"/>
               </a:rPr>
+              <a:t>Beyond Lending — Where Custos Applies</a:t>
+            </a:r>
+          </a:p>
+        </p:txBody>
+      </p:sp>
+      <p:sp>
+        <p:nvSpPr>
+          <p:cNvPr id="3" name="Subtitle 2">
+            <a:extLst>
+              <a:ext uri="{FF2B5EF4-FFF2-40B4-BE49-F238E27FC236}">
+                <a16:creationId xmlns:a16="http://schemas.microsoft.com/office/drawing/2014/main" id="{255E737C-85F2-47BC-AD38-AD8B001473B7}"/>
+              </a:ext>
+            </a:extLst>
+          </p:cNvPr>
+          <p:cNvSpPr>
+            <a:spLocks noGrp="1"/>
+          </p:cNvSpPr>
+          <p:nvPr>
+            <p:ph type="subTitle" idx="1"/>
+          </p:nvPr>
+        </p:nvSpPr>
+        <p:spPr>
+          <a:xfrm>
+            <a:off x="1684867" y="1574800"/>
+            <a:ext cx="9694333" cy="4614333"/>
+          </a:xfrm>
+        </p:spPr>
+        <p:txBody>
+          <a:bodyPr>
+            <a:normAutofit/>
+          </a:bodyPr>
+          <a:lstStyle/>
+          <a:p>
+            <a:pPr marL="0" indent="0" algn="l">
+              <a:spcBef>
+                <a:spcPts val="0"/>
+              </a:spcBef>
+              <a:buNone/>
+            </a:pPr>
+            <a:r>
+              <a:rPr lang="en-US" sz="1300" b="0" i="0" dirty="0">
+                <a:latin typeface="Calibri" panose="020F0502020204030204" pitchFamily="34" charset="0"/>
+                <a:ea typeface="Calibri" panose="020F0502020204030204" pitchFamily="34" charset="0"/>
+                <a:cs typeface="Calibri" panose="020F0502020204030204" pitchFamily="34" charset="0"/>
+              </a:rPr>
+              <a:t>Custos gates any model whose output triggers an action that can be allowed, held for a person, or blocked. A new domain is configuration — inputs, context, rules, weights — not code. Two are demonstrated; the rest are stated, not claimed.</a:t>
+            </a:r>
+          </a:p>
+        </p:txBody>
+      </p:sp>
+      <p:pic>
+        <p:nvPicPr>
+          <p:cNvPr id="5" name="Graphic 4">
+            <a:extLst>
+              <a:ext uri="{FF2B5EF4-FFF2-40B4-BE49-F238E27FC236}">
+                <a16:creationId xmlns:a16="http://schemas.microsoft.com/office/drawing/2014/main" id="{E7125167-8301-4D88-B79A-A8DA3C19E0D6}"/>
+              </a:ext>
+            </a:extLst>
+          </p:cNvPr>
+          <p:cNvPicPr>
+            <a:picLocks noChangeAspect="1"/>
+          </p:cNvPicPr>
+          <p:nvPr/>
+        </p:nvPicPr>
+        <p:blipFill>
+          <a:blip r:embed="rId2">
+            <a:extLst>
+              <a:ext uri="{96DAC541-7B7A-43D3-8B79-37D633B846F1}">
+                <asvg:svgBlip xmlns:asvg="http://schemas.microsoft.com/office/drawing/2016/SVG/main" r:embed="rId3"/>
+              </a:ext>
+            </a:extLst>
+          </a:blip>
+          <a:stretch>
+            <a:fillRect/>
+          </a:stretch>
+        </p:blipFill>
+        <p:spPr>
+          <a:xfrm>
+            <a:off x="127001" y="86782"/>
+            <a:ext cx="1159932" cy="1159932"/>
+          </a:xfrm>
+          <a:prstGeom prst="rect">
+            <a:avLst/>
+          </a:prstGeom>
+        </p:spPr>
+      </p:pic>
+      <p:sp>
+        <p:nvSpPr>
+          <p:cNvPr id="4" name="Date Placeholder 3">
+            <a:extLst>
+              <a:ext uri="{FF2B5EF4-FFF2-40B4-BE49-F238E27FC236}">
+                <a16:creationId xmlns:a16="http://schemas.microsoft.com/office/drawing/2014/main" id="{35032362-C5A5-4DBF-AD79-DE6FB7439999}"/>
+              </a:ext>
+            </a:extLst>
+          </p:cNvPr>
+          <p:cNvSpPr>
+            <a:spLocks noGrp="1"/>
+          </p:cNvSpPr>
+          <p:nvPr>
+            <p:ph type="dt" sz="half" idx="10"/>
+          </p:nvPr>
+        </p:nvSpPr>
+        <p:spPr/>
+        <p:txBody>
+          <a:bodyPr/>
+          <a:lstStyle/>
+          <a:p>
+            <a:fld id="{64C96E34-94C0-49E4-A53B-4A44141FD3C8}" type="datetime3">
+              <a:rPr lang="en-US" smtClean="0"/>
+              <a:t>17 October 2026</a:t>
+            </a:fld>
+            <a:endParaRPr lang="en-US" dirty="0"/>
+          </a:p>
+        </p:txBody>
+      </p:sp>
+      <p:sp>
+        <p:nvSpPr>
+          <p:cNvPr id="6" name="Slide Number Placeholder 5">
+            <a:extLst>
+              <a:ext uri="{FF2B5EF4-FFF2-40B4-BE49-F238E27FC236}">
+                <a16:creationId xmlns:a16="http://schemas.microsoft.com/office/drawing/2014/main" id="{115AAB64-5B51-4B5A-B69E-D96362CE6E74}"/>
+              </a:ext>
+            </a:extLst>
+          </p:cNvPr>
+          <p:cNvSpPr>
+            <a:spLocks noGrp="1"/>
+          </p:cNvSpPr>
+          <p:nvPr>
+            <p:ph type="sldNum" sz="quarter" idx="12"/>
+          </p:nvPr>
+        </p:nvSpPr>
+        <p:spPr/>
+        <p:txBody>
+          <a:bodyPr/>
+          <a:lstStyle/>
+          <a:p>
+            <a:fld id="{D57F1E4F-1CFF-5643-939E-217C01CDF565}" type="slidenum">
+              <a:rPr lang="en-US" smtClean="0"/>
+              <a:pPr/>
+              <a:t>3</a:t>
+            </a:fld>
+            <a:endParaRPr lang="en-US" dirty="0"/>
+          </a:p>
+        </p:txBody>
+      </p:sp>
+      <p:sp>
+        <p:nvSpPr>
+          <p:cNvPr id="7" name="Footer Placeholder 6">
+            <a:extLst>
+              <a:ext uri="{FF2B5EF4-FFF2-40B4-BE49-F238E27FC236}">
+                <a16:creationId xmlns:a16="http://schemas.microsoft.com/office/drawing/2014/main" id="{8683C6DF-27D9-468B-A1AB-FE568488FE57}"/>
+              </a:ext>
+            </a:extLst>
+          </p:cNvPr>
+          <p:cNvSpPr>
+            <a:spLocks noGrp="1"/>
+          </p:cNvSpPr>
+          <p:nvPr>
+            <p:ph type="ftr" sz="quarter" idx="11"/>
+          </p:nvPr>
+        </p:nvSpPr>
+        <p:spPr/>
+        <p:txBody>
+          <a:bodyPr/>
+          <a:lstStyle/>
+          <a:p>
+            <a:r>
+              <a:rPr lang="en-US"/>
+              <a:t>Dept of AI &amp; DS</a:t>
+            </a:r>
+            <a:endParaRPr lang="en-US" dirty="0"/>
+          </a:p>
+        </p:txBody>
+      </p:sp>
+      <p:graphicFrame>
+        <p:nvGraphicFramePr>
+          <p:cNvPr id="8" name="Table 7"/>
+          <p:cNvGraphicFramePr>
+            <a:graphicFrameLocks noGrp="1"/>
+          </p:cNvGraphicFramePr>
+          <p:nvPr/>
+        </p:nvGraphicFramePr>
+        <p:xfrm>
+          <a:off x="960120" y="2331720"/>
+          <a:ext cx="10241278" cy="177800"/>
+        </p:xfrm>
+        <a:graphic>
+          <a:graphicData uri="http://schemas.openxmlformats.org/drawingml/2006/table">
+            <a:tbl>
+              <a:tblPr firstRow="1">
+                <a:tableStyleId>{5C22544A-7EE6-4342-B048-85BDC9FD1C3A}</a:tableStyleId>
+              </a:tblPr>
+              <a:tblGrid>
+                <a:gridCol w="1741017"/>
+                <a:gridCol w="2560320"/>
+                <a:gridCol w="3277209"/>
+                <a:gridCol w="2662732"/>
+              </a:tblGrid>
+              <a:tr h="25400">
+                <a:tc>
+                  <a:txBody>
+                    <a:bodyPr wrap="square"/>
+                    <a:lstStyle/>
+                    <a:p>
+                      <a:r>
+                        <a:rPr sz="1100" b="1">
+                          <a:solidFill>
+                            <a:srgbClr val="FFFFFF"/>
+                          </a:solidFill>
+                          <a:latin typeface="Calibri"/>
+                        </a:rPr>
+                        <a:t>Domain</a:t>
+                      </a:r>
+                    </a:p>
+                  </a:txBody>
+                  <a:tcPr marL="63500" marR="63500" marT="38100" marB="38100">
+                    <a:solidFill>
+                      <a:srgbClr val="1F5CA8"/>
+                    </a:solidFill>
+                  </a:tcPr>
+                </a:tc>
+                <a:tc>
+                  <a:txBody>
+                    <a:bodyPr wrap="square"/>
+                    <a:lstStyle/>
+                    <a:p>
+                      <a:r>
+                        <a:rPr sz="1100" b="1">
+                          <a:solidFill>
+                            <a:srgbClr val="FFFFFF"/>
+                          </a:solidFill>
+                          <a:latin typeface="Calibri"/>
+                        </a:rPr>
+                        <a:t>Action Custos gates</a:t>
+                      </a:r>
+                    </a:p>
+                  </a:txBody>
+                  <a:tcPr marL="63500" marR="63500" marT="38100" marB="38100">
+                    <a:solidFill>
+                      <a:srgbClr val="1F5CA8"/>
+                    </a:solidFill>
+                  </a:tcPr>
+                </a:tc>
+                <a:tc>
+                  <a:txBody>
+                    <a:bodyPr wrap="square"/>
+                    <a:lstStyle/>
+                    <a:p>
+                      <a:r>
+                        <a:rPr sz="1100" b="1">
+                          <a:solidFill>
+                            <a:srgbClr val="FFFFFF"/>
+                          </a:solidFill>
+                          <a:latin typeface="Calibri"/>
+                        </a:rPr>
+                        <a:t>What it catches</a:t>
+                      </a:r>
+                    </a:p>
+                  </a:txBody>
+                  <a:tcPr marL="63500" marR="63500" marT="38100" marB="38100">
+                    <a:solidFill>
+                      <a:srgbClr val="1F5CA8"/>
+                    </a:solidFill>
+                  </a:tcPr>
+                </a:tc>
+                <a:tc>
+                  <a:txBody>
+                    <a:bodyPr wrap="square"/>
+                    <a:lstStyle/>
+                    <a:p>
+                      <a:r>
+                        <a:rPr sz="1100" b="1">
+                          <a:solidFill>
+                            <a:srgbClr val="FFFFFF"/>
+                          </a:solidFill>
+                          <a:latin typeface="Calibri"/>
+                        </a:rPr>
+                        <a:t>Status</a:t>
+                      </a:r>
+                    </a:p>
+                  </a:txBody>
+                  <a:tcPr marL="63500" marR="63500" marT="38100" marB="38100">
+                    <a:solidFill>
+                      <a:srgbClr val="1F5CA8"/>
+                    </a:solidFill>
+                  </a:tcPr>
+                </a:tc>
+              </a:tr>
+              <a:tr h="25400">
+                <a:tc>
+                  <a:txBody>
+                    <a:bodyPr wrap="square"/>
+                    <a:lstStyle/>
+                    <a:p>
+                      <a:r>
+                        <a:rPr sz="1100" b="0">
+                          <a:latin typeface="Calibri"/>
+                        </a:rPr>
+                        <a:t>Lending</a:t>
+                      </a:r>
+                    </a:p>
+                  </a:txBody>
+                  <a:tcPr marL="63500" marR="63500" marT="38100" marB="38100">
+                    <a:noFill/>
+                  </a:tcPr>
+                </a:tc>
+                <a:tc>
+                  <a:txBody>
+                    <a:bodyPr wrap="square"/>
+                    <a:lstStyle/>
+                    <a:p>
+                      <a:r>
+                        <a:rPr sz="1100" b="0">
+                          <a:latin typeface="Calibri"/>
+                        </a:rPr>
+                        <a:t>Approve or disburse a loan</a:t>
+                      </a:r>
+                    </a:p>
+                  </a:txBody>
+                  <a:tcPr marL="63500" marR="63500" marT="38100" marB="38100">
+                    <a:noFill/>
+                  </a:tcPr>
+                </a:tc>
+                <a:tc>
+                  <a:txBody>
+                    <a:bodyPr wrap="square"/>
+                    <a:lstStyle/>
+                    <a:p>
+                      <a:r>
+                        <a:rPr sz="1100" b="0">
+                          <a:latin typeface="Calibri"/>
+                        </a:rPr>
+                        <a:t>Population drift, unusual amounts, policy limits</a:t>
+                      </a:r>
+                    </a:p>
+                  </a:txBody>
+                  <a:tcPr marL="63500" marR="63500" marT="38100" marB="38100">
+                    <a:noFill/>
+                  </a:tcPr>
+                </a:tc>
+                <a:tc>
+                  <a:txBody>
+                    <a:bodyPr wrap="square"/>
+                    <a:lstStyle/>
+                    <a:p>
+                      <a:r>
+                        <a:rPr sz="1100" b="0">
+                          <a:latin typeface="Calibri"/>
+                        </a:rPr>
+                        <a:t>Demonstrated · field study on 589,186 loans · EU AI Act high-risk</a:t>
+                      </a:r>
+                    </a:p>
+                  </a:txBody>
+                  <a:tcPr marL="63500" marR="63500" marT="38100" marB="38100">
+                    <a:noFill/>
+                  </a:tcPr>
+                </a:tc>
+              </a:tr>
+              <a:tr h="25400">
+                <a:tc>
+                  <a:txBody>
+                    <a:bodyPr wrap="square"/>
+                    <a:lstStyle/>
+                    <a:p>
+                      <a:r>
+                        <a:rPr sz="1100" b="0">
+                          <a:latin typeface="Calibri"/>
+                        </a:rPr>
+                        <a:t>AI agents (refunds)</a:t>
+                      </a:r>
+                    </a:p>
+                  </a:txBody>
+                  <a:tcPr marL="63500" marR="63500" marT="38100" marB="38100">
+                    <a:solidFill>
+                      <a:srgbClr val="F4F6F9"/>
+                    </a:solidFill>
+                  </a:tcPr>
+                </a:tc>
+                <a:tc>
+                  <a:txBody>
+                    <a:bodyPr wrap="square"/>
+                    <a:lstStyle/>
+                    <a:p>
+                      <a:r>
+                        <a:rPr sz="1100" b="0">
+                          <a:latin typeface="Calibri"/>
+                        </a:rPr>
+                        <a:t>Any tool action — here, issuing a refund</a:t>
+                      </a:r>
+                    </a:p>
+                  </a:txBody>
+                  <a:tcPr marL="63500" marR="63500" marT="38100" marB="38100">
+                    <a:solidFill>
+                      <a:srgbClr val="F4F6F9"/>
+                    </a:solidFill>
+                  </a:tcPr>
+                </a:tc>
+                <a:tc>
+                  <a:txBody>
+                    <a:bodyPr wrap="square"/>
+                    <a:lstStyle/>
+                    <a:p>
+                      <a:r>
+                        <a:rPr sz="1100" b="0">
+                          <a:latin typeface="Calibri"/>
+                        </a:rPr>
+                        <a:t>Runaway loops, manipulated requests, a fraud ring</a:t>
+                      </a:r>
+                    </a:p>
+                  </a:txBody>
+                  <a:tcPr marL="63500" marR="63500" marT="38100" marB="38100">
+                    <a:solidFill>
+                      <a:srgbClr val="F4F6F9"/>
+                    </a:solidFill>
+                  </a:tcPr>
+                </a:tc>
+                <a:tc>
+                  <a:txBody>
+                    <a:bodyPr wrap="square"/>
+                    <a:lstStyle/>
+                    <a:p>
+                      <a:r>
+                        <a:rPr sz="1100" b="0">
+                          <a:latin typeface="Calibri"/>
+                        </a:rPr>
+                        <a:t>Demonstrated · live demo 3, no code change</a:t>
+                      </a:r>
+                    </a:p>
+                  </a:txBody>
+                  <a:tcPr marL="63500" marR="63500" marT="38100" marB="38100">
+                    <a:solidFill>
+                      <a:srgbClr val="F4F6F9"/>
+                    </a:solidFill>
+                  </a:tcPr>
+                </a:tc>
+              </a:tr>
+              <a:tr h="25400">
+                <a:tc>
+                  <a:txBody>
+                    <a:bodyPr wrap="square"/>
+                    <a:lstStyle/>
+                    <a:p>
+                      <a:r>
+                        <a:rPr sz="1100" b="0">
+                          <a:latin typeface="Calibri"/>
+                        </a:rPr>
+                        <a:t>Dynamic pricing</a:t>
+                      </a:r>
+                    </a:p>
+                  </a:txBody>
+                  <a:tcPr marL="63500" marR="63500" marT="38100" marB="38100">
+                    <a:noFill/>
+                  </a:tcPr>
+                </a:tc>
+                <a:tc>
+                  <a:txBody>
+                    <a:bodyPr wrap="square"/>
+                    <a:lstStyle/>
+                    <a:p>
+                      <a:r>
+                        <a:rPr sz="1100" b="0">
+                          <a:latin typeface="Calibri"/>
+                        </a:rPr>
+                        <a:t>Publish a price</a:t>
+                      </a:r>
+                    </a:p>
+                  </a:txBody>
+                  <a:tcPr marL="63500" marR="63500" marT="38100" marB="38100">
+                    <a:noFill/>
+                  </a:tcPr>
+                </a:tc>
+                <a:tc>
+                  <a:txBody>
+                    <a:bodyPr wrap="square"/>
+                    <a:lstStyle/>
+                    <a:p>
+                      <a:r>
+                        <a:rPr sz="1100" b="0">
+                          <a:latin typeface="Calibri"/>
+                        </a:rPr>
+                        <a:t>A price far outside its normal range; never below cost</a:t>
+                      </a:r>
+                    </a:p>
+                  </a:txBody>
+                  <a:tcPr marL="63500" marR="63500" marT="38100" marB="38100">
+                    <a:noFill/>
+                  </a:tcPr>
+                </a:tc>
+                <a:tc>
+                  <a:txBody>
+                    <a:bodyPr wrap="square"/>
+                    <a:lstStyle/>
+                    <a:p>
+                      <a:r>
+                        <a:rPr sz="1100" b="0">
+                          <a:latin typeface="Calibri"/>
+                        </a:rPr>
+                        <a:t>Applies by configuration</a:t>
+                      </a:r>
+                    </a:p>
+                  </a:txBody>
+                  <a:tcPr marL="63500" marR="63500" marT="38100" marB="38100">
+                    <a:noFill/>
+                  </a:tcPr>
+                </a:tc>
+              </a:tr>
+              <a:tr h="25400">
+                <a:tc>
+                  <a:txBody>
+                    <a:bodyPr wrap="square"/>
+                    <a:lstStyle/>
+                    <a:p>
+                      <a:r>
+                        <a:rPr sz="1100" b="0">
+                          <a:latin typeface="Calibri"/>
+                        </a:rPr>
+                        <a:t>Medical triage</a:t>
+                      </a:r>
+                    </a:p>
+                  </a:txBody>
+                  <a:tcPr marL="63500" marR="63500" marT="38100" marB="38100">
+                    <a:solidFill>
+                      <a:srgbClr val="F4F6F9"/>
+                    </a:solidFill>
+                  </a:tcPr>
+                </a:tc>
+                <a:tc>
+                  <a:txBody>
+                    <a:bodyPr wrap="square"/>
+                    <a:lstStyle/>
+                    <a:p>
+                      <a:r>
+                        <a:rPr sz="1100" b="0">
+                          <a:latin typeface="Calibri"/>
+                        </a:rPr>
+                        <a:t>Route a patient as low priority</a:t>
+                      </a:r>
+                    </a:p>
+                  </a:txBody>
+                  <a:tcPr marL="63500" marR="63500" marT="38100" marB="38100">
+                    <a:solidFill>
+                      <a:srgbClr val="F4F6F9"/>
+                    </a:solidFill>
+                  </a:tcPr>
+                </a:tc>
+                <a:tc>
+                  <a:txBody>
+                    <a:bodyPr wrap="square"/>
+                    <a:lstStyle/>
+                    <a:p>
+                      <a:r>
+                        <a:rPr sz="1100" b="0">
+                          <a:latin typeface="Calibri"/>
+                        </a:rPr>
+                        <a:t>A stuck device feed; red-flag symptoms always to a human</a:t>
+                      </a:r>
+                    </a:p>
+                  </a:txBody>
+                  <a:tcPr marL="63500" marR="63500" marT="38100" marB="38100">
+                    <a:solidFill>
+                      <a:srgbClr val="F4F6F9"/>
+                    </a:solidFill>
+                  </a:tcPr>
+                </a:tc>
+                <a:tc>
+                  <a:txBody>
+                    <a:bodyPr wrap="square"/>
+                    <a:lstStyle/>
+                    <a:p>
+                      <a:r>
+                        <a:rPr sz="1100" b="0">
+                          <a:latin typeface="Calibri"/>
+                        </a:rPr>
+                        <a:t>Applies by configuration · EU AI Act high-risk</a:t>
+                      </a:r>
+                    </a:p>
+                  </a:txBody>
+                  <a:tcPr marL="63500" marR="63500" marT="38100" marB="38100">
+                    <a:solidFill>
+                      <a:srgbClr val="F4F6F9"/>
+                    </a:solidFill>
+                  </a:tcPr>
+                </a:tc>
+              </a:tr>
+              <a:tr h="25400">
+                <a:tc>
+                  <a:txBody>
+                    <a:bodyPr wrap="square"/>
+                    <a:lstStyle/>
+                    <a:p>
+                      <a:r>
+                        <a:rPr sz="1100" b="0">
+                          <a:latin typeface="Calibri"/>
+                        </a:rPr>
+                        <a:t>Hiring and screening</a:t>
+                      </a:r>
+                    </a:p>
+                  </a:txBody>
+                  <a:tcPr marL="63500" marR="63500" marT="38100" marB="38100">
+                    <a:noFill/>
+                  </a:tcPr>
+                </a:tc>
+                <a:tc>
+                  <a:txBody>
+                    <a:bodyPr wrap="square"/>
+                    <a:lstStyle/>
+                    <a:p>
+                      <a:r>
+                        <a:rPr sz="1100" b="0">
+                          <a:latin typeface="Calibri"/>
+                        </a:rPr>
+                        <a:t>Auto-reject a candidate</a:t>
+                      </a:r>
+                    </a:p>
+                  </a:txBody>
+                  <a:tcPr marL="63500" marR="63500" marT="38100" marB="38100">
+                    <a:noFill/>
+                  </a:tcPr>
+                </a:tc>
+                <a:tc>
+                  <a:txBody>
+                    <a:bodyPr wrap="square"/>
+                    <a:lstStyle/>
+                    <a:p>
+                      <a:r>
+                        <a:rPr sz="1100" b="0">
+                          <a:latin typeface="Calibri"/>
+                        </a:rPr>
+                        <a:t>Applicant-pool shift; rule: REVIEW only, never auto-reject</a:t>
+                      </a:r>
+                    </a:p>
+                  </a:txBody>
+                  <a:tcPr marL="63500" marR="63500" marT="38100" marB="38100">
+                    <a:noFill/>
+                  </a:tcPr>
+                </a:tc>
+                <a:tc>
+                  <a:txBody>
+                    <a:bodyPr wrap="square"/>
+                    <a:lstStyle/>
+                    <a:p>
+                      <a:r>
+                        <a:rPr sz="1100" b="0">
+                          <a:latin typeface="Calibri"/>
+                        </a:rPr>
+                        <a:t>Applies by configuration · EU AI Act high-risk</a:t>
+                      </a:r>
+                    </a:p>
+                  </a:txBody>
+                  <a:tcPr marL="63500" marR="63500" marT="38100" marB="38100">
+                    <a:noFill/>
+                  </a:tcPr>
+                </a:tc>
+              </a:tr>
+              <a:tr h="25400">
+                <a:tc>
+                  <a:txBody>
+                    <a:bodyPr wrap="square"/>
+                    <a:lstStyle/>
+                    <a:p>
+                      <a:r>
+                        <a:rPr sz="1100" b="0">
+                          <a:latin typeface="Calibri"/>
+                        </a:rPr>
+                        <a:t>Insurance claims</a:t>
+                      </a:r>
+                    </a:p>
+                  </a:txBody>
+                  <a:tcPr marL="63500" marR="63500" marT="38100" marB="38100">
+                    <a:solidFill>
+                      <a:srgbClr val="F4F6F9"/>
+                    </a:solidFill>
+                  </a:tcPr>
+                </a:tc>
+                <a:tc>
+                  <a:txBody>
+                    <a:bodyPr wrap="square"/>
+                    <a:lstStyle/>
+                    <a:p>
+                      <a:r>
+                        <a:rPr sz="1100" b="0">
+                          <a:latin typeface="Calibri"/>
+                        </a:rPr>
+                        <a:t>Auto-pay a claim</a:t>
+                      </a:r>
+                    </a:p>
+                  </a:txBody>
+                  <a:tcPr marL="63500" marR="63500" marT="38100" marB="38100">
+                    <a:solidFill>
+                      <a:srgbClr val="F4F6F9"/>
+                    </a:solidFill>
+                  </a:tcPr>
+                </a:tc>
+                <a:tc>
+                  <a:txBody>
+                    <a:bodyPr wrap="square"/>
+                    <a:lstStyle/>
+                    <a:p>
+                      <a:r>
+                        <a:rPr sz="1100" b="0">
+                          <a:latin typeface="Calibri"/>
+                        </a:rPr>
+                        <a:t>Claim-mix shift after a disaster; bursts per policy</a:t>
+                      </a:r>
+                    </a:p>
+                  </a:txBody>
+                  <a:tcPr marL="63500" marR="63500" marT="38100" marB="38100">
+                    <a:solidFill>
+                      <a:srgbClr val="F4F6F9"/>
+                    </a:solidFill>
+                  </a:tcPr>
+                </a:tc>
+                <a:tc>
+                  <a:txBody>
+                    <a:bodyPr wrap="square"/>
+                    <a:lstStyle/>
+                    <a:p>
+                      <a:r>
+                        <a:rPr sz="1100" b="0">
+                          <a:latin typeface="Calibri"/>
+                        </a:rPr>
+                        <a:t>Applies by configuration</a:t>
+                      </a:r>
+                    </a:p>
+                  </a:txBody>
+                  <a:tcPr marL="63500" marR="63500" marT="38100" marB="38100">
+                    <a:solidFill>
+                      <a:srgbClr val="F4F6F9"/>
+                    </a:solidFill>
+                  </a:tcPr>
+                </a:tc>
+              </a:tr>
+            </a:tbl>
+          </a:graphicData>
+        </a:graphic>
+      </p:graphicFrame>
+    </p:spTree>
+    <p:extLst>
+      <p:ext uri="{BB962C8B-B14F-4D97-AF65-F5344CB8AC3E}">
+        <p14:creationId xmlns:p14="http://schemas.microsoft.com/office/powerpoint/2010/main" val="3231882420"/>
+      </p:ext>
+    </p:extLst>
+  </p:cSld>
+  <p:clrMapOvr>
+    <a:masterClrMapping/>
+  </p:clrMapOvr>
+</p:sld>
+</file>
+
+<file path=ppt/slides/slide24.xml><?xml version="1.0" encoding="utf-8"?>
+<p:sld xmlns:a="http://schemas.openxmlformats.org/drawingml/2006/main" xmlns:r="http://schemas.openxmlformats.org/officeDocument/2006/relationships" xmlns:p="http://schemas.openxmlformats.org/presentationml/2006/main">
+  <p:cSld>
+    <p:spTree>
+      <p:nvGrpSpPr>
+        <p:cNvPr id="1" name=""/>
+        <p:cNvGrpSpPr/>
+        <p:nvPr/>
+      </p:nvGrpSpPr>
+      <p:grpSpPr>
+        <a:xfrm>
+          <a:off x="0" y="0"/>
+          <a:ext cx="0" cy="0"/>
+          <a:chOff x="0" y="0"/>
+          <a:chExt cx="0" cy="0"/>
+        </a:xfrm>
+      </p:grpSpPr>
+      <p:sp>
+        <p:nvSpPr>
+          <p:cNvPr id="2" name="Title 1">
+            <a:extLst>
+              <a:ext uri="{FF2B5EF4-FFF2-40B4-BE49-F238E27FC236}">
+                <a16:creationId xmlns:a16="http://schemas.microsoft.com/office/drawing/2014/main" id="{BD1A189D-22D1-4D1A-9E04-C6134EC51F8B}"/>
+              </a:ext>
+            </a:extLst>
+          </p:cNvPr>
+          <p:cNvSpPr>
+            <a:spLocks noGrp="1"/>
+          </p:cNvSpPr>
+          <p:nvPr>
+            <p:ph type="ctrTitle"/>
+          </p:nvPr>
+        </p:nvSpPr>
+        <p:spPr>
+          <a:xfrm>
+            <a:off x="1684868" y="203198"/>
+            <a:ext cx="9694332" cy="880535"/>
+          </a:xfrm>
+        </p:spPr>
+        <p:txBody>
+          <a:bodyPr>
+            <a:normAutofit/>
+          </a:bodyPr>
+          <a:lstStyle/>
+          <a:p>
+            <a:pPr marL="0" indent="0" algn="l">
+              <a:spcBef>
+                <a:spcPts val="0"/>
+              </a:spcBef>
+              <a:buNone/>
+            </a:pPr>
+            <a:r>
+              <a:rPr lang="en-US" sz="3200" b="1" i="0" dirty="0">
+                <a:latin typeface="Calibri" panose="020F0502020204030204" pitchFamily="34" charset="0"/>
+                <a:ea typeface="Calibri" panose="020F0502020204030204" pitchFamily="34" charset="0"/>
+                <a:cs typeface="Calibri" panose="020F0502020204030204" pitchFamily="34" charset="0"/>
+              </a:rPr>
               <a:t>Work Plan to the Final Review</a:t>
             </a:r>
           </a:p>
@@ -11384,7 +12191,7 @@
 </p:sld>
 </file>
 
-<file path=ppt/slides/slide24.xml><?xml version="1.0" encoding="utf-8"?>
+<file path=ppt/slides/slide25.xml><?xml version="1.0" encoding="utf-8"?>
 <p:sld xmlns:a="http://schemas.openxmlformats.org/drawingml/2006/main" xmlns:r="http://schemas.openxmlformats.org/officeDocument/2006/relationships" xmlns:p="http://schemas.openxmlformats.org/presentationml/2006/main">
   <p:cSld>
     <p:spTree>

</xml_diff>

<commit_message>
docs(review2): closing tagline and two-line quote on the conclusion slide
Slide 15 now ends on a large tagline, "Models decide. Custos makes sure they
still deserve to.", with a two-line quote beneath it. The quote is original to
the project, so nothing is misattributed. The team table moves down to 4.6 in
to make room. The speech notes add the pause-and-read cue.

Co-Authored-By: Claude Opus 5.5 <noreply@anthropic.com>
</commit_message>
<xml_diff>
--- a/docs/presentations/Custos_Phase2_Review2.pptx
+++ b/docs/presentations/Custos_Phase2_Review2.pptx
@@ -6256,6 +6256,54 @@
               <a:t>Now: a live demo — three scenarios, two domains.</a:t>
             </a:r>
           </a:p>
+          <a:p>
+            <a:pPr marL="0" indent="0" algn="ctr">
+              <a:spcBef>
+                <a:spcPts val="600"/>
+              </a:spcBef>
+              <a:buNone/>
+            </a:pPr>
+            <a:r>
+              <a:rPr lang="en-US" sz="2600" b="1" i="0" dirty="0">
+                <a:latin typeface="Calibri" panose="020F0502020204030204" pitchFamily="34" charset="0"/>
+                <a:ea typeface="Calibri" panose="020F0502020204030204" pitchFamily="34" charset="0"/>
+                <a:cs typeface="Calibri" panose="020F0502020204030204" pitchFamily="34" charset="0"/>
+              </a:rPr>
+              <a:t>Models decide. Custos makes sure they still deserve to.</a:t>
+            </a:r>
+          </a:p>
+          <a:p>
+            <a:pPr marL="0" indent="0" algn="ctr">
+              <a:spcBef>
+                <a:spcPts val="300"/>
+              </a:spcBef>
+              <a:buNone/>
+            </a:pPr>
+            <a:r>
+              <a:rPr lang="en-US" sz="1600" b="0" i="1" dirty="0">
+                <a:latin typeface="Calibri" panose="020F0502020204030204" pitchFamily="34" charset="0"/>
+                <a:ea typeface="Calibri" panose="020F0502020204030204" pitchFamily="34" charset="0"/>
+                <a:cs typeface="Calibri" panose="020F0502020204030204" pitchFamily="34" charset="0"/>
+              </a:rPr>
+              <a:t>“A model that is running is not a model that can be trusted.</a:t>
+            </a:r>
+          </a:p>
+          <a:p>
+            <a:pPr marL="0" indent="0" algn="ctr">
+              <a:spcBef>
+                <a:spcPts val="0"/>
+              </a:spcBef>
+              <a:buNone/>
+            </a:pPr>
+            <a:r>
+              <a:rPr lang="en-US" sz="1600" b="0" i="1" dirty="0">
+                <a:latin typeface="Calibri" panose="020F0502020204030204" pitchFamily="34" charset="0"/>
+                <a:ea typeface="Calibri" panose="020F0502020204030204" pitchFamily="34" charset="0"/>
+                <a:cs typeface="Calibri" panose="020F0502020204030204" pitchFamily="34" charset="0"/>
+              </a:rPr>
+              <a:t>Custos checks the difference — every decision, every time.”</a:t>
+            </a:r>
+          </a:p>
         </p:txBody>
       </p:sp>
       <p:pic>
@@ -6391,7 +6439,7 @@
           <p:nvPr/>
         </p:nvGraphicFramePr>
         <p:xfrm>
-          <a:off x="960120" y="3291840"/>
+          <a:off x="960120" y="4206240"/>
           <a:ext cx="10241279" cy="101600"/>
         </p:xfrm>
         <a:graphic>

</xml_diff>